<commit_message>
feat: update VyaparMarg project presentations and platform implementation
</commit_message>
<xml_diff>
--- a/VyaparMarg_Project_Presentation.pptx
+++ b/VyaparMarg_Project_Presentation.pptx
@@ -8638,6 +8638,366 @@
           </a:p>
         </p:txBody>
       </p:sp>
+      <p:sp>
+        <p:nvSpPr>
+          <p:cNvPr id="100055" name="TextBox 2"/>
+          <p:cNvSpPr/>
+          <p:nvPr/>
+        </p:nvSpPr>
+        <p:spPr>
+          <a:xfrm>
+            <a:off x="640080" y="1234440"/>
+            <a:ext cx="3383280" cy="292608"/>
+          </a:xfrm>
+          <a:prstGeom prst="roundRect">
+            <a:avLst/>
+          </a:prstGeom>
+          <a:solidFill>
+            <a:srgbClr val="EEF5FF"/>
+          </a:solidFill>
+          <a:ln>
+            <a:noFill/>
+          </a:ln>
+        </p:spPr>
+        <p:txBody>
+          <a:bodyPr lIns="73152" tIns="73152" rIns="73152" bIns="73152"/>
+          <a:lstStyle/>
+          <a:p>
+            <a:pPr algn="l"/>
+            <a:r>
+              <a:rPr lang="en-US" sz="1700" b="1">
+                <a:solidFill>
+                  <a:srgbClr val="145DA0"/>
+                </a:solidFill>
+              </a:rPr>
+              <a:t>01  Discover</a:t>
+            </a:r>
+          </a:p>
+        </p:txBody>
+      </p:sp>
+      <p:sp>
+        <p:nvSpPr>
+          <p:cNvPr id="100056" name="TextBox 3"/>
+          <p:cNvSpPr/>
+          <p:nvPr/>
+        </p:nvSpPr>
+        <p:spPr>
+          <a:xfrm>
+            <a:off x="640080" y="1545336"/>
+            <a:ext cx="3383280" cy="704088"/>
+          </a:xfrm>
+          <a:prstGeom prst="rect">
+            <a:avLst/>
+          </a:prstGeom>
+          <a:noFill/>
+          <a:ln>
+            <a:noFill/>
+          </a:ln>
+        </p:spPr>
+        <p:txBody>
+          <a:bodyPr lIns="73152" tIns="73152" rIns="73152" bIns="73152"/>
+          <a:lstStyle/>
+          <a:p>
+            <a:pPr algn="l"/>
+            <a:r>
+              <a:rPr lang="en-US" sz="1200" b="0">
+                <a:solidFill>
+                  <a:srgbClr val="344563"/>
+                </a:solidFill>
+              </a:rPr>
+              <a:t>Make relevant rural schemes easy to find.</a:t>
+            </a:r>
+          </a:p>
+        </p:txBody>
+      </p:sp>
+      <p:sp>
+        <p:nvSpPr>
+          <p:cNvPr id="100057" name="TextBox 4"/>
+          <p:cNvSpPr/>
+          <p:nvPr/>
+        </p:nvSpPr>
+        <p:spPr>
+          <a:xfrm>
+            <a:off x="4434840" y="1234440"/>
+            <a:ext cx="3383280" cy="292608"/>
+          </a:xfrm>
+          <a:prstGeom prst="roundRect">
+            <a:avLst/>
+          </a:prstGeom>
+          <a:solidFill>
+            <a:srgbClr val="FFF4E8"/>
+          </a:solidFill>
+          <a:ln>
+            <a:noFill/>
+          </a:ln>
+        </p:spPr>
+        <p:txBody>
+          <a:bodyPr lIns="73152" tIns="73152" rIns="73152" bIns="73152"/>
+          <a:lstStyle/>
+          <a:p>
+            <a:pPr algn="l"/>
+            <a:r>
+              <a:rPr lang="en-US" sz="1700" b="1">
+                <a:solidFill>
+                  <a:srgbClr val="F97316"/>
+                </a:solidFill>
+              </a:rPr>
+              <a:t>02  Understand</a:t>
+            </a:r>
+          </a:p>
+        </p:txBody>
+      </p:sp>
+      <p:sp>
+        <p:nvSpPr>
+          <p:cNvPr id="100058" name="TextBox 5"/>
+          <p:cNvSpPr/>
+          <p:nvPr/>
+        </p:nvSpPr>
+        <p:spPr>
+          <a:xfrm>
+            <a:off x="4434840" y="1545336"/>
+            <a:ext cx="3383280" cy="704088"/>
+          </a:xfrm>
+          <a:prstGeom prst="rect">
+            <a:avLst/>
+          </a:prstGeom>
+          <a:noFill/>
+          <a:ln>
+            <a:noFill/>
+          </a:ln>
+        </p:spPr>
+        <p:txBody>
+          <a:bodyPr lIns="73152" tIns="73152" rIns="73152" bIns="73152"/>
+          <a:lstStyle/>
+          <a:p>
+            <a:pPr algn="l"/>
+            <a:r>
+              <a:rPr lang="en-US" sz="1200" b="0">
+                <a:solidFill>
+                  <a:srgbClr val="344563"/>
+                </a:solidFill>
+              </a:rPr>
+              <a:t>Explain eligibility in clear local-language responses.</a:t>
+            </a:r>
+          </a:p>
+        </p:txBody>
+      </p:sp>
+      <p:sp>
+        <p:nvSpPr>
+          <p:cNvPr id="100059" name="TextBox 6"/>
+          <p:cNvSpPr/>
+          <p:nvPr/>
+        </p:nvSpPr>
+        <p:spPr>
+          <a:xfrm>
+            <a:off x="640080" y="2651760"/>
+            <a:ext cx="3383280" cy="292608"/>
+          </a:xfrm>
+          <a:prstGeom prst="roundRect">
+            <a:avLst/>
+          </a:prstGeom>
+          <a:solidFill>
+            <a:srgbClr val="ECFDF3"/>
+          </a:solidFill>
+          <a:ln>
+            <a:noFill/>
+          </a:ln>
+        </p:spPr>
+        <p:txBody>
+          <a:bodyPr lIns="73152" tIns="73152" rIns="73152" bIns="73152"/>
+          <a:lstStyle/>
+          <a:p>
+            <a:pPr algn="l"/>
+            <a:r>
+              <a:rPr lang="en-US" sz="1700" b="1">
+                <a:solidFill>
+                  <a:srgbClr val="138A5E"/>
+                </a:solidFill>
+              </a:rPr>
+              <a:t>03  Validate</a:t>
+            </a:r>
+          </a:p>
+        </p:txBody>
+      </p:sp>
+      <p:sp>
+        <p:nvSpPr>
+          <p:cNvPr id="100060" name="TextBox 7"/>
+          <p:cNvSpPr/>
+          <p:nvPr/>
+        </p:nvSpPr>
+        <p:spPr>
+          <a:xfrm>
+            <a:off x="640080" y="2962656"/>
+            <a:ext cx="3383280" cy="704088"/>
+          </a:xfrm>
+          <a:prstGeom prst="rect">
+            <a:avLst/>
+          </a:prstGeom>
+          <a:noFill/>
+          <a:ln>
+            <a:noFill/>
+          </a:ln>
+        </p:spPr>
+        <p:txBody>
+          <a:bodyPr lIns="73152" tIns="73152" rIns="73152" bIns="73152"/>
+          <a:lstStyle/>
+          <a:p>
+            <a:pPr algn="l"/>
+            <a:r>
+              <a:rPr lang="en-US" sz="1200" b="0">
+                <a:solidFill>
+                  <a:srgbClr val="344563"/>
+                </a:solidFill>
+              </a:rPr>
+              <a:t>Use structured rules for consistent, auditable results.</a:t>
+            </a:r>
+          </a:p>
+        </p:txBody>
+      </p:sp>
+      <p:sp>
+        <p:nvSpPr>
+          <p:cNvPr id="100061" name="TextBox 8"/>
+          <p:cNvSpPr/>
+          <p:nvPr/>
+        </p:nvSpPr>
+        <p:spPr>
+          <a:xfrm>
+            <a:off x="4434840" y="2651760"/>
+            <a:ext cx="3383280" cy="292608"/>
+          </a:xfrm>
+          <a:prstGeom prst="roundRect">
+            <a:avLst/>
+          </a:prstGeom>
+          <a:solidFill>
+            <a:srgbClr val="F5F3FF"/>
+          </a:solidFill>
+          <a:ln>
+            <a:noFill/>
+          </a:ln>
+        </p:spPr>
+        <p:txBody>
+          <a:bodyPr lIns="73152" tIns="73152" rIns="73152" bIns="73152"/>
+          <a:lstStyle/>
+          <a:p>
+            <a:pPr algn="l"/>
+            <a:r>
+              <a:rPr lang="en-US" sz="1700" b="1">
+                <a:solidFill>
+                  <a:srgbClr val="7C3AED"/>
+                </a:solidFill>
+              </a:rPr>
+              <a:t>04  Apply</a:t>
+            </a:r>
+          </a:p>
+        </p:txBody>
+      </p:sp>
+      <p:sp>
+        <p:nvSpPr>
+          <p:cNvPr id="100062" name="TextBox 9"/>
+          <p:cNvSpPr/>
+          <p:nvPr/>
+        </p:nvSpPr>
+        <p:spPr>
+          <a:xfrm>
+            <a:off x="4434840" y="2962656"/>
+            <a:ext cx="3383280" cy="704088"/>
+          </a:xfrm>
+          <a:prstGeom prst="rect">
+            <a:avLst/>
+          </a:prstGeom>
+          <a:noFill/>
+          <a:ln>
+            <a:noFill/>
+          </a:ln>
+        </p:spPr>
+        <p:txBody>
+          <a:bodyPr lIns="73152" tIns="73152" rIns="73152" bIns="73152"/>
+          <a:lstStyle/>
+          <a:p>
+            <a:pPr algn="l"/>
+            <a:r>
+              <a:rPr lang="en-US" sz="1200" b="0">
+                <a:solidFill>
+                  <a:srgbClr val="344563"/>
+                </a:solidFill>
+              </a:rPr>
+              <a:t>Track portal steps and application progress.</a:t>
+            </a:r>
+          </a:p>
+        </p:txBody>
+      </p:sp>
+      <p:sp>
+        <p:nvSpPr>
+          <p:cNvPr id="100063" name="TextBox 10"/>
+          <p:cNvSpPr/>
+          <p:nvPr/>
+        </p:nvSpPr>
+        <p:spPr>
+          <a:xfrm>
+            <a:off x="2542032" y="4069080"/>
+            <a:ext cx="3383280" cy="292608"/>
+          </a:xfrm>
+          <a:prstGeom prst="roundRect">
+            <a:avLst/>
+          </a:prstGeom>
+          <a:solidFill>
+            <a:srgbClr val="FFF7ED"/>
+          </a:solidFill>
+          <a:ln>
+            <a:noFill/>
+          </a:ln>
+        </p:spPr>
+        <p:txBody>
+          <a:bodyPr lIns="73152" tIns="73152" rIns="73152" bIns="73152"/>
+          <a:lstStyle/>
+          <a:p>
+            <a:pPr algn="l"/>
+            <a:r>
+              <a:rPr lang="en-US" sz="1700" b="1">
+                <a:solidFill>
+                  <a:srgbClr val="C2410C"/>
+                </a:solidFill>
+              </a:rPr>
+              <a:t>05  Include</a:t>
+            </a:r>
+          </a:p>
+        </p:txBody>
+      </p:sp>
+      <p:sp>
+        <p:nvSpPr>
+          <p:cNvPr id="100064" name="TextBox 11"/>
+          <p:cNvSpPr/>
+          <p:nvPr/>
+        </p:nvSpPr>
+        <p:spPr>
+          <a:xfrm>
+            <a:off x="2542032" y="4379976"/>
+            <a:ext cx="3383280" cy="704088"/>
+          </a:xfrm>
+          <a:prstGeom prst="rect">
+            <a:avLst/>
+          </a:prstGeom>
+          <a:noFill/>
+          <a:ln>
+            <a:noFill/>
+          </a:ln>
+        </p:spPr>
+        <p:txBody>
+          <a:bodyPr lIns="73152" tIns="73152" rIns="73152" bIns="73152"/>
+          <a:lstStyle/>
+          <a:p>
+            <a:pPr algn="l"/>
+            <a:r>
+              <a:rPr lang="en-US" sz="1200" b="0">
+                <a:solidFill>
+                  <a:srgbClr val="344563"/>
+                </a:solidFill>
+              </a:rPr>
+              <a:t>Design for low bandwidth, multilingual and mobile-first use.</a:t>
+            </a:r>
+          </a:p>
+        </p:txBody>
+      </p:sp>
     </p:spTree>
   </p:cSld>
   <p:clrMapOvr>
@@ -8712,6 +9072,331 @@
           </a:p>
         </p:txBody>
       </p:sp>
+      <p:sp>
+        <p:nvSpPr>
+          <p:cNvPr id="100065" name="TextBox 2"/>
+          <p:cNvSpPr/>
+          <p:nvPr/>
+        </p:nvSpPr>
+        <p:spPr>
+          <a:xfrm>
+            <a:off x="640080" y="1234440"/>
+            <a:ext cx="3474720" cy="292608"/>
+          </a:xfrm>
+          <a:prstGeom prst="roundRect">
+            <a:avLst/>
+          </a:prstGeom>
+          <a:solidFill>
+            <a:srgbClr val="EEF5FF"/>
+          </a:solidFill>
+          <a:ln>
+            <a:noFill/>
+          </a:ln>
+        </p:spPr>
+        <p:txBody>
+          <a:bodyPr lIns="73152" tIns="73152" rIns="73152" bIns="73152"/>
+          <a:lstStyle/>
+          <a:p>
+            <a:pPr algn="l"/>
+            <a:r>
+              <a:rPr lang="en-US" sz="1700" b="1">
+                <a:solidFill>
+                  <a:srgbClr val="145DA0"/>
+                </a:solidFill>
+              </a:rPr>
+              <a:t>Frontend</a:t>
+            </a:r>
+          </a:p>
+        </p:txBody>
+      </p:sp>
+      <p:sp>
+        <p:nvSpPr>
+          <p:cNvPr id="100066" name="TextBox 3"/>
+          <p:cNvSpPr/>
+          <p:nvPr/>
+        </p:nvSpPr>
+        <p:spPr>
+          <a:xfrm>
+            <a:off x="640080" y="1545336"/>
+            <a:ext cx="3474720" cy="886968"/>
+          </a:xfrm>
+          <a:prstGeom prst="rect">
+            <a:avLst/>
+          </a:prstGeom>
+          <a:noFill/>
+          <a:ln>
+            <a:noFill/>
+          </a:ln>
+        </p:spPr>
+        <p:txBody>
+          <a:bodyPr lIns="73152" tIns="73152" rIns="73152" bIns="73152"/>
+          <a:lstStyle/>
+          <a:p>
+            <a:pPr algn="l"/>
+            <a:r>
+              <a:rPr lang="en-US" sz="1200" b="0">
+                <a:solidFill>
+                  <a:srgbClr val="344563"/>
+                </a:solidFill>
+              </a:rPr>
+              <a:t>Expo / React Native mobile app, multilingual assistant UI, profile and applications views.</a:t>
+            </a:r>
+          </a:p>
+        </p:txBody>
+      </p:sp>
+      <p:sp>
+        <p:nvSpPr>
+          <p:cNvPr id="100067" name="TextBox 4"/>
+          <p:cNvSpPr/>
+          <p:nvPr/>
+        </p:nvSpPr>
+        <p:spPr>
+          <a:xfrm>
+            <a:off x="4434840" y="1234440"/>
+            <a:ext cx="3474720" cy="292608"/>
+          </a:xfrm>
+          <a:prstGeom prst="roundRect">
+            <a:avLst/>
+          </a:prstGeom>
+          <a:solidFill>
+            <a:srgbClr val="FFF4E8"/>
+          </a:solidFill>
+          <a:ln>
+            <a:noFill/>
+          </a:ln>
+        </p:spPr>
+        <p:txBody>
+          <a:bodyPr lIns="73152" tIns="73152" rIns="73152" bIns="73152"/>
+          <a:lstStyle/>
+          <a:p>
+            <a:pPr algn="l"/>
+            <a:r>
+              <a:rPr lang="en-US" sz="1700" b="1">
+                <a:solidFill>
+                  <a:srgbClr val="F97316"/>
+                </a:solidFill>
+              </a:rPr>
+              <a:t>Backend</a:t>
+            </a:r>
+          </a:p>
+        </p:txBody>
+      </p:sp>
+      <p:sp>
+        <p:nvSpPr>
+          <p:cNvPr id="100068" name="TextBox 5"/>
+          <p:cNvSpPr/>
+          <p:nvPr/>
+        </p:nvSpPr>
+        <p:spPr>
+          <a:xfrm>
+            <a:off x="4434840" y="1545336"/>
+            <a:ext cx="3474720" cy="886968"/>
+          </a:xfrm>
+          <a:prstGeom prst="rect">
+            <a:avLst/>
+          </a:prstGeom>
+          <a:noFill/>
+          <a:ln>
+            <a:noFill/>
+          </a:ln>
+        </p:spPr>
+        <p:txBody>
+          <a:bodyPr lIns="73152" tIns="73152" rIns="73152" bIns="73152"/>
+          <a:lstStyle/>
+          <a:p>
+            <a:pPr algn="l"/>
+            <a:r>
+              <a:rPr lang="en-US" sz="1200" b="0">
+                <a:solidFill>
+                  <a:srgbClr val="344563"/>
+                </a:solidFill>
+              </a:rPr>
+              <a:t>FastAPI REST API under /api/v1 for profiles, assistant messages, schemes and applications.</a:t>
+            </a:r>
+          </a:p>
+        </p:txBody>
+      </p:sp>
+      <p:sp>
+        <p:nvSpPr>
+          <p:cNvPr id="100069" name="TextBox 6"/>
+          <p:cNvSpPr/>
+          <p:nvPr/>
+        </p:nvSpPr>
+        <p:spPr>
+          <a:xfrm>
+            <a:off x="640080" y="2880360"/>
+            <a:ext cx="3474720" cy="292608"/>
+          </a:xfrm>
+          <a:prstGeom prst="roundRect">
+            <a:avLst/>
+          </a:prstGeom>
+          <a:solidFill>
+            <a:srgbClr val="ECFDF3"/>
+          </a:solidFill>
+          <a:ln>
+            <a:noFill/>
+          </a:ln>
+        </p:spPr>
+        <p:txBody>
+          <a:bodyPr lIns="73152" tIns="73152" rIns="73152" bIns="73152"/>
+          <a:lstStyle/>
+          <a:p>
+            <a:pPr algn="l"/>
+            <a:r>
+              <a:rPr lang="en-US" sz="1700" b="1">
+                <a:solidFill>
+                  <a:srgbClr val="138A5E"/>
+                </a:solidFill>
+              </a:rPr>
+              <a:t>Data &amp; security</a:t>
+            </a:r>
+          </a:p>
+        </p:txBody>
+      </p:sp>
+      <p:sp>
+        <p:nvSpPr>
+          <p:cNvPr id="100070" name="TextBox 7"/>
+          <p:cNvSpPr/>
+          <p:nvPr/>
+        </p:nvSpPr>
+        <p:spPr>
+          <a:xfrm>
+            <a:off x="640080" y="3191256"/>
+            <a:ext cx="3474720" cy="886968"/>
+          </a:xfrm>
+          <a:prstGeom prst="rect">
+            <a:avLst/>
+          </a:prstGeom>
+          <a:noFill/>
+          <a:ln>
+            <a:noFill/>
+          </a:ln>
+        </p:spPr>
+        <p:txBody>
+          <a:bodyPr lIns="73152" tIns="73152" rIns="73152" bIns="73152"/>
+          <a:lstStyle/>
+          <a:p>
+            <a:pPr algn="l"/>
+            <a:r>
+              <a:rPr lang="en-US" sz="1200" b="0">
+                <a:solidFill>
+                  <a:srgbClr val="344563"/>
+                </a:solidFill>
+              </a:rPr>
+              <a:t>Supabase Auth, Postgres, RLS, Storage metadata and server-side service credentials.</a:t>
+            </a:r>
+          </a:p>
+        </p:txBody>
+      </p:sp>
+      <p:sp>
+        <p:nvSpPr>
+          <p:cNvPr id="100071" name="TextBox 8"/>
+          <p:cNvSpPr/>
+          <p:nvPr/>
+        </p:nvSpPr>
+        <p:spPr>
+          <a:xfrm>
+            <a:off x="4434840" y="2880360"/>
+            <a:ext cx="3474720" cy="292608"/>
+          </a:xfrm>
+          <a:prstGeom prst="roundRect">
+            <a:avLst/>
+          </a:prstGeom>
+          <a:solidFill>
+            <a:srgbClr val="F5F3FF"/>
+          </a:solidFill>
+          <a:ln>
+            <a:noFill/>
+          </a:ln>
+        </p:spPr>
+        <p:txBody>
+          <a:bodyPr lIns="73152" tIns="73152" rIns="73152" bIns="73152"/>
+          <a:lstStyle/>
+          <a:p>
+            <a:pPr algn="l"/>
+            <a:r>
+              <a:rPr lang="en-US" sz="1700" b="1">
+                <a:solidFill>
+                  <a:srgbClr val="7C3AED"/>
+                </a:solidFill>
+              </a:rPr>
+              <a:t>Decision layer</a:t>
+            </a:r>
+          </a:p>
+        </p:txBody>
+      </p:sp>
+      <p:sp>
+        <p:nvSpPr>
+          <p:cNvPr id="100072" name="TextBox 9"/>
+          <p:cNvSpPr/>
+          <p:nvPr/>
+        </p:nvSpPr>
+        <p:spPr>
+          <a:xfrm>
+            <a:off x="4434840" y="3191256"/>
+            <a:ext cx="3474720" cy="886968"/>
+          </a:xfrm>
+          <a:prstGeom prst="rect">
+            <a:avLst/>
+          </a:prstGeom>
+          <a:noFill/>
+          <a:ln>
+            <a:noFill/>
+          </a:ln>
+        </p:spPr>
+        <p:txBody>
+          <a:bodyPr lIns="73152" tIns="73152" rIns="73152" bIns="73152"/>
+          <a:lstStyle/>
+          <a:p>
+            <a:pPr algn="l"/>
+            <a:r>
+              <a:rPr lang="en-US" sz="1200" b="0">
+                <a:solidFill>
+                  <a:srgbClr val="344563"/>
+                </a:solidFill>
+              </a:rPr>
+              <a:t>LLM extracts and explains; deterministic scheme rules produce eligibility status.</a:t>
+            </a:r>
+          </a:p>
+        </p:txBody>
+      </p:sp>
+      <p:sp>
+        <p:nvSpPr>
+          <p:cNvPr id="100073" name="TextBox 10"/>
+          <p:cNvSpPr/>
+          <p:nvPr/>
+        </p:nvSpPr>
+        <p:spPr>
+          <a:xfrm>
+            <a:off x="868680" y="4892040"/>
+            <a:ext cx="6766560" cy="594360"/>
+          </a:xfrm>
+          <a:prstGeom prst="roundRect">
+            <a:avLst/>
+          </a:prstGeom>
+          <a:solidFill>
+            <a:srgbClr val="FFF7ED"/>
+          </a:solidFill>
+          <a:ln>
+            <a:noFill/>
+          </a:ln>
+        </p:spPr>
+        <p:txBody>
+          <a:bodyPr lIns="73152" tIns="73152" rIns="73152" bIns="73152"/>
+          <a:lstStyle/>
+          <a:p>
+            <a:pPr algn="ctr"/>
+            <a:r>
+              <a:rPr lang="en-US" sz="1600" b="1">
+                <a:solidFill>
+                  <a:srgbClr val="0F2747"/>
+                </a:solidFill>
+              </a:rPr>
+              <a:t>Quality bar: trustworthy recommendations, explicit errors, testable contracts and no service-role key in client apps.</a:t>
+            </a:r>
+          </a:p>
+        </p:txBody>
+      </p:sp>
     </p:spTree>
   </p:cSld>
   <p:clrMapOvr>
@@ -8782,6 +9467,331 @@
           </a:p>
         </p:txBody>
       </p:sp>
+      <p:sp>
+        <p:nvSpPr>
+          <p:cNvPr id="100074" name="TextBox 2"/>
+          <p:cNvSpPr/>
+          <p:nvPr/>
+        </p:nvSpPr>
+        <p:spPr>
+          <a:xfrm>
+            <a:off x="640080" y="1325880"/>
+            <a:ext cx="3474720" cy="292608"/>
+          </a:xfrm>
+          <a:prstGeom prst="roundRect">
+            <a:avLst/>
+          </a:prstGeom>
+          <a:solidFill>
+            <a:srgbClr val="EEF5FF"/>
+          </a:solidFill>
+          <a:ln>
+            <a:noFill/>
+          </a:ln>
+        </p:spPr>
+        <p:txBody>
+          <a:bodyPr lIns="73152" tIns="73152" rIns="73152" bIns="73152"/>
+          <a:lstStyle/>
+          <a:p>
+            <a:pPr algn="l"/>
+            <a:r>
+              <a:rPr lang="en-US" sz="1700" b="1">
+                <a:solidFill>
+                  <a:srgbClr val="145DA0"/>
+                </a:solidFill>
+              </a:rPr>
+              <a:t>Phase 2</a:t>
+            </a:r>
+          </a:p>
+        </p:txBody>
+      </p:sp>
+      <p:sp>
+        <p:nvSpPr>
+          <p:cNvPr id="100075" name="TextBox 3"/>
+          <p:cNvSpPr/>
+          <p:nvPr/>
+        </p:nvSpPr>
+        <p:spPr>
+          <a:xfrm>
+            <a:off x="640080" y="1636776"/>
+            <a:ext cx="3474720" cy="841248"/>
+          </a:xfrm>
+          <a:prstGeom prst="rect">
+            <a:avLst/>
+          </a:prstGeom>
+          <a:noFill/>
+          <a:ln>
+            <a:noFill/>
+          </a:ln>
+        </p:spPr>
+        <p:txBody>
+          <a:bodyPr lIns="73152" tIns="73152" rIns="73152" bIns="73152"/>
+          <a:lstStyle/>
+          <a:p>
+            <a:pPr algn="l"/>
+            <a:r>
+              <a:rPr lang="en-US" sz="1200" b="0">
+                <a:solidFill>
+                  <a:srgbClr val="344563"/>
+                </a:solidFill>
+              </a:rPr>
+              <a:t>Offline-friendly flows, document capture and stronger voice interaction.</a:t>
+            </a:r>
+          </a:p>
+        </p:txBody>
+      </p:sp>
+      <p:sp>
+        <p:nvSpPr>
+          <p:cNvPr id="100076" name="TextBox 4"/>
+          <p:cNvSpPr/>
+          <p:nvPr/>
+        </p:nvSpPr>
+        <p:spPr>
+          <a:xfrm>
+            <a:off x="4434840" y="1325880"/>
+            <a:ext cx="3474720" cy="292608"/>
+          </a:xfrm>
+          <a:prstGeom prst="roundRect">
+            <a:avLst/>
+          </a:prstGeom>
+          <a:solidFill>
+            <a:srgbClr val="FFF4E8"/>
+          </a:solidFill>
+          <a:ln>
+            <a:noFill/>
+          </a:ln>
+        </p:spPr>
+        <p:txBody>
+          <a:bodyPr lIns="73152" tIns="73152" rIns="73152" bIns="73152"/>
+          <a:lstStyle/>
+          <a:p>
+            <a:pPr algn="l"/>
+            <a:r>
+              <a:rPr lang="en-US" sz="1700" b="1">
+                <a:solidFill>
+                  <a:srgbClr val="F97316"/>
+                </a:solidFill>
+              </a:rPr>
+              <a:t>Phase 3</a:t>
+            </a:r>
+          </a:p>
+        </p:txBody>
+      </p:sp>
+      <p:sp>
+        <p:nvSpPr>
+          <p:cNvPr id="100077" name="TextBox 5"/>
+          <p:cNvSpPr/>
+          <p:nvPr/>
+        </p:nvSpPr>
+        <p:spPr>
+          <a:xfrm>
+            <a:off x="4434840" y="1636776"/>
+            <a:ext cx="3474720" cy="841248"/>
+          </a:xfrm>
+          <a:prstGeom prst="rect">
+            <a:avLst/>
+          </a:prstGeom>
+          <a:noFill/>
+          <a:ln>
+            <a:noFill/>
+          </a:ln>
+        </p:spPr>
+        <p:txBody>
+          <a:bodyPr lIns="73152" tIns="73152" rIns="73152" bIns="73152"/>
+          <a:lstStyle/>
+          <a:p>
+            <a:pPr algn="l"/>
+            <a:r>
+              <a:rPr lang="en-US" sz="1200" b="0">
+                <a:solidFill>
+                  <a:srgbClr val="344563"/>
+                </a:solidFill>
+              </a:rPr>
+              <a:t>More state schemes, dialect coverage and local support networks.</a:t>
+            </a:r>
+          </a:p>
+        </p:txBody>
+      </p:sp>
+      <p:sp>
+        <p:nvSpPr>
+          <p:cNvPr id="100078" name="TextBox 6"/>
+          <p:cNvSpPr/>
+          <p:nvPr/>
+        </p:nvSpPr>
+        <p:spPr>
+          <a:xfrm>
+            <a:off x="640080" y="2971800"/>
+            <a:ext cx="3474720" cy="292608"/>
+          </a:xfrm>
+          <a:prstGeom prst="roundRect">
+            <a:avLst/>
+          </a:prstGeom>
+          <a:solidFill>
+            <a:srgbClr val="ECFDF3"/>
+          </a:solidFill>
+          <a:ln>
+            <a:noFill/>
+          </a:ln>
+        </p:spPr>
+        <p:txBody>
+          <a:bodyPr lIns="73152" tIns="73152" rIns="73152" bIns="73152"/>
+          <a:lstStyle/>
+          <a:p>
+            <a:pPr algn="l"/>
+            <a:r>
+              <a:rPr lang="en-US" sz="1700" b="1">
+                <a:solidFill>
+                  <a:srgbClr val="138A5E"/>
+                </a:solidFill>
+              </a:rPr>
+              <a:t>Phase 4</a:t>
+            </a:r>
+          </a:p>
+        </p:txBody>
+      </p:sp>
+      <p:sp>
+        <p:nvSpPr>
+          <p:cNvPr id="100079" name="TextBox 7"/>
+          <p:cNvSpPr/>
+          <p:nvPr/>
+        </p:nvSpPr>
+        <p:spPr>
+          <a:xfrm>
+            <a:off x="640080" y="3282696"/>
+            <a:ext cx="3474720" cy="841248"/>
+          </a:xfrm>
+          <a:prstGeom prst="rect">
+            <a:avLst/>
+          </a:prstGeom>
+          <a:noFill/>
+          <a:ln>
+            <a:noFill/>
+          </a:ln>
+        </p:spPr>
+        <p:txBody>
+          <a:bodyPr lIns="73152" tIns="73152" rIns="73152" bIns="73152"/>
+          <a:lstStyle/>
+          <a:p>
+            <a:pPr algn="l"/>
+            <a:r>
+              <a:rPr lang="en-US" sz="1200" b="0">
+                <a:solidFill>
+                  <a:srgbClr val="344563"/>
+                </a:solidFill>
+              </a:rPr>
+              <a:t>Outcome tracking, reminders and assisted portal completion.</a:t>
+            </a:r>
+          </a:p>
+        </p:txBody>
+      </p:sp>
+      <p:sp>
+        <p:nvSpPr>
+          <p:cNvPr id="100080" name="TextBox 8"/>
+          <p:cNvSpPr/>
+          <p:nvPr/>
+        </p:nvSpPr>
+        <p:spPr>
+          <a:xfrm>
+            <a:off x="4434840" y="2971800"/>
+            <a:ext cx="3474720" cy="292608"/>
+          </a:xfrm>
+          <a:prstGeom prst="roundRect">
+            <a:avLst/>
+          </a:prstGeom>
+          <a:solidFill>
+            <a:srgbClr val="F5F3FF"/>
+          </a:solidFill>
+          <a:ln>
+            <a:noFill/>
+          </a:ln>
+        </p:spPr>
+        <p:txBody>
+          <a:bodyPr lIns="73152" tIns="73152" rIns="73152" bIns="73152"/>
+          <a:lstStyle/>
+          <a:p>
+            <a:pPr algn="l"/>
+            <a:r>
+              <a:rPr lang="en-US" sz="1700" b="1">
+                <a:solidFill>
+                  <a:srgbClr val="7C3AED"/>
+                </a:solidFill>
+              </a:rPr>
+              <a:t>Long term</a:t>
+            </a:r>
+          </a:p>
+        </p:txBody>
+      </p:sp>
+      <p:sp>
+        <p:nvSpPr>
+          <p:cNvPr id="100081" name="TextBox 9"/>
+          <p:cNvSpPr/>
+          <p:nvPr/>
+        </p:nvSpPr>
+        <p:spPr>
+          <a:xfrm>
+            <a:off x="4434840" y="3282696"/>
+            <a:ext cx="3474720" cy="841248"/>
+          </a:xfrm>
+          <a:prstGeom prst="rect">
+            <a:avLst/>
+          </a:prstGeom>
+          <a:noFill/>
+          <a:ln>
+            <a:noFill/>
+          </a:ln>
+        </p:spPr>
+        <p:txBody>
+          <a:bodyPr lIns="73152" tIns="73152" rIns="73152" bIns="73152"/>
+          <a:lstStyle/>
+          <a:p>
+            <a:pPr algn="l"/>
+            <a:r>
+              <a:rPr lang="en-US" sz="1200" b="0">
+                <a:solidFill>
+                  <a:srgbClr val="344563"/>
+                </a:solidFill>
+              </a:rPr>
+              <a:t>Extension support, analytics dashboards and ecosystem partnerships.</a:t>
+            </a:r>
+          </a:p>
+        </p:txBody>
+      </p:sp>
+      <p:sp>
+        <p:nvSpPr>
+          <p:cNvPr id="100082" name="TextBox 10"/>
+          <p:cNvSpPr/>
+          <p:nvPr/>
+        </p:nvSpPr>
+        <p:spPr>
+          <a:xfrm>
+            <a:off x="1051560" y="4892040"/>
+            <a:ext cx="6400800" cy="594360"/>
+          </a:xfrm>
+          <a:prstGeom prst="roundRect">
+            <a:avLst/>
+          </a:prstGeom>
+          <a:solidFill>
+            <a:srgbClr val="FFF7ED"/>
+          </a:solidFill>
+          <a:ln>
+            <a:noFill/>
+          </a:ln>
+        </p:spPr>
+        <p:txBody>
+          <a:bodyPr lIns="73152" tIns="73152" rIns="73152" bIns="73152"/>
+          <a:lstStyle/>
+          <a:p>
+            <a:pPr algn="ctr"/>
+            <a:r>
+              <a:rPr lang="en-US" sz="1800" b="1">
+                <a:solidFill>
+                  <a:srgbClr val="0F2747"/>
+                </a:solidFill>
+              </a:rPr>
+              <a:t>Scale with evidence: learn from verified outcomes while keeping decisions explainable.</a:t>
+            </a:r>
+          </a:p>
+        </p:txBody>
+      </p:sp>
     </p:spTree>
   </p:cSld>
   <p:clrMapOvr>
@@ -8851,6 +9861,371 @@
           </a:p>
         </p:txBody>
       </p:sp>
+      <p:pic>
+        <p:nvPicPr>
+          <p:cNvPr id="100083" name="Picture 1" descr="VyaparMarg app icon"/>
+          <p:cNvPicPr>
+            <a:picLocks noChangeAspect="1"/>
+          </p:cNvPicPr>
+          <p:nvPr/>
+        </p:nvPicPr>
+        <p:blipFill>
+          <a:blip r:embed="R01fa3d7652b842f5"/>
+          <a:stretch>
+            <a:fillRect/>
+          </a:stretch>
+        </p:blipFill>
+        <p:spPr>
+          <a:xfrm>
+            <a:off x="685800" y="1234440"/>
+            <a:ext cx="822960" cy="822960"/>
+          </a:xfrm>
+          <a:prstGeom prst="rect">
+            <a:avLst/>
+          </a:prstGeom>
+        </p:spPr>
+      </p:pic>
+      <p:sp>
+        <p:nvSpPr>
+          <p:cNvPr id="100084" name="TextBox 2"/>
+          <p:cNvSpPr/>
+          <p:nvPr/>
+        </p:nvSpPr>
+        <p:spPr>
+          <a:xfrm>
+            <a:off x="1691640" y="1234440"/>
+            <a:ext cx="2651760" cy="365760"/>
+          </a:xfrm>
+          <a:prstGeom prst="rect">
+            <a:avLst/>
+          </a:prstGeom>
+          <a:noFill/>
+          <a:ln>
+            <a:noFill/>
+          </a:ln>
+        </p:spPr>
+        <p:txBody>
+          <a:bodyPr lIns="73152" tIns="73152" rIns="73152" bIns="73152"/>
+          <a:lstStyle/>
+          <a:p>
+            <a:pPr algn="l"/>
+            <a:r>
+              <a:rPr lang="en-US" sz="2000" b="1">
+                <a:solidFill>
+                  <a:srgbClr val="145DA0"/>
+                </a:solidFill>
+              </a:rPr>
+              <a:t>Rangesh Gupta</a:t>
+            </a:r>
+          </a:p>
+        </p:txBody>
+      </p:sp>
+      <p:sp>
+        <p:nvSpPr>
+          <p:cNvPr id="100085" name="TextBox 3"/>
+          <p:cNvSpPr/>
+          <p:nvPr/>
+        </p:nvSpPr>
+        <p:spPr>
+          <a:xfrm>
+            <a:off x="1691640" y="1664208"/>
+            <a:ext cx="2926080" cy="914400"/>
+          </a:xfrm>
+          <a:prstGeom prst="rect">
+            <a:avLst/>
+          </a:prstGeom>
+          <a:noFill/>
+          <a:ln>
+            <a:noFill/>
+          </a:ln>
+        </p:spPr>
+        <p:txBody>
+          <a:bodyPr lIns="73152" tIns="73152" rIns="73152" bIns="73152"/>
+          <a:lstStyle/>
+          <a:p>
+            <a:pPr algn="l"/>
+            <a:r>
+              <a:rPr lang="en-US" sz="1400" b="0">
+                <a:solidFill>
+                  <a:srgbClr val="344563"/>
+                </a:solidFill>
+              </a:rPr>
+              <a:t>Roll No. 53  |  SE CPMN A</a:t>
+            </a:r>
+          </a:p>
+          <a:p>
+            <a:pPr algn="l"/>
+            <a:r>
+              <a:rPr lang="en-US" sz="1400" b="0">
+                <a:solidFill>
+                  <a:srgbClr val="344563"/>
+                </a:solidFill>
+              </a:rPr>
+              <a:t>Project: VyaparMarg</a:t>
+            </a:r>
+          </a:p>
+          <a:p>
+            <a:pPr algn="l"/>
+            <a:r>
+              <a:rPr lang="en-US" sz="1400" b="0">
+                <a:solidFill>
+                  <a:srgbClr val="344563"/>
+                </a:solidFill>
+              </a:rPr>
+              <a:t>Focus: product concept, mobile UX and project integration</a:t>
+            </a:r>
+          </a:p>
+        </p:txBody>
+      </p:sp>
+      <p:sp>
+        <p:nvSpPr>
+          <p:cNvPr id="100086" name="TextBox 4"/>
+          <p:cNvSpPr/>
+          <p:nvPr/>
+        </p:nvSpPr>
+        <p:spPr>
+          <a:xfrm>
+            <a:off x="4709160" y="1234440"/>
+            <a:ext cx="3246120" cy="777240"/>
+          </a:xfrm>
+          <a:prstGeom prst="roundRect">
+            <a:avLst/>
+          </a:prstGeom>
+          <a:solidFill>
+            <a:srgbClr val="F97316"/>
+          </a:solidFill>
+          <a:ln>
+            <a:noFill/>
+          </a:ln>
+        </p:spPr>
+        <p:txBody>
+          <a:bodyPr lIns="73152" tIns="73152" rIns="73152" bIns="73152"/>
+          <a:lstStyle/>
+          <a:p>
+            <a:pPr algn="ctr"/>
+            <a:r>
+              <a:rPr lang="en-US" sz="1700" b="1">
+                <a:solidFill>
+                  <a:srgbClr val="FFFFFF"/>
+                </a:solidFill>
+              </a:rPr>
+              <a:t>Other team members - add name, roll no., role and project screenshot here</a:t>
+            </a:r>
+          </a:p>
+        </p:txBody>
+      </p:sp>
+      <p:sp>
+        <p:nvSpPr>
+          <p:cNvPr id="100087" name="TextBox 5"/>
+          <p:cNvSpPr/>
+          <p:nvPr/>
+        </p:nvSpPr>
+        <p:spPr>
+          <a:xfrm>
+            <a:off x="685800" y="3063240"/>
+            <a:ext cx="2148840" cy="1371600"/>
+          </a:xfrm>
+          <a:prstGeom prst="roundRect">
+            <a:avLst/>
+          </a:prstGeom>
+          <a:solidFill>
+            <a:srgbClr val="F8FAFC"/>
+          </a:solidFill>
+          <a:ln>
+            <a:noFill/>
+          </a:ln>
+        </p:spPr>
+        <p:txBody>
+          <a:bodyPr lIns="73152" tIns="73152" rIns="73152" bIns="73152"/>
+          <a:lstStyle/>
+          <a:p>
+            <a:pPr algn="ctr"/>
+            <a:r>
+              <a:rPr lang="en-US" sz="1500" b="0">
+                <a:solidFill>
+                  <a:srgbClr val="64748B"/>
+                </a:solidFill>
+              </a:rPr>
+              <a:t>Member 2</a:t>
+            </a:r>
+          </a:p>
+          <a:p>
+            <a:pPr algn="ctr"/>
+            <a:r>
+              <a:rPr lang="en-US" sz="1500" b="0">
+                <a:solidFill>
+                  <a:srgbClr val="64748B"/>
+                </a:solidFill>
+              </a:rPr>
+              <a:t>Name / Roll No.</a:t>
+            </a:r>
+          </a:p>
+          <a:p>
+            <a:pPr algn="ctr"/>
+            <a:r>
+              <a:rPr lang="en-US" sz="1500" b="0">
+                <a:solidFill>
+                  <a:srgbClr val="64748B"/>
+                </a:solidFill>
+              </a:rPr>
+              <a:t>Contribution / screenshot</a:t>
+            </a:r>
+          </a:p>
+        </p:txBody>
+      </p:sp>
+      <p:sp>
+        <p:nvSpPr>
+          <p:cNvPr id="100088" name="TextBox 6"/>
+          <p:cNvSpPr/>
+          <p:nvPr/>
+        </p:nvSpPr>
+        <p:spPr>
+          <a:xfrm>
+            <a:off x="3246120" y="3063240"/>
+            <a:ext cx="2148840" cy="1371600"/>
+          </a:xfrm>
+          <a:prstGeom prst="roundRect">
+            <a:avLst/>
+          </a:prstGeom>
+          <a:solidFill>
+            <a:srgbClr val="F8FAFC"/>
+          </a:solidFill>
+          <a:ln>
+            <a:noFill/>
+          </a:ln>
+        </p:spPr>
+        <p:txBody>
+          <a:bodyPr lIns="73152" tIns="73152" rIns="73152" bIns="73152"/>
+          <a:lstStyle/>
+          <a:p>
+            <a:pPr algn="ctr"/>
+            <a:r>
+              <a:rPr lang="en-US" sz="1500" b="0">
+                <a:solidFill>
+                  <a:srgbClr val="64748B"/>
+                </a:solidFill>
+              </a:rPr>
+              <a:t>Member 3</a:t>
+            </a:r>
+          </a:p>
+          <a:p>
+            <a:pPr algn="ctr"/>
+            <a:r>
+              <a:rPr lang="en-US" sz="1500" b="0">
+                <a:solidFill>
+                  <a:srgbClr val="64748B"/>
+                </a:solidFill>
+              </a:rPr>
+              <a:t>Name / Roll No.</a:t>
+            </a:r>
+          </a:p>
+          <a:p>
+            <a:pPr algn="ctr"/>
+            <a:r>
+              <a:rPr lang="en-US" sz="1500" b="0">
+                <a:solidFill>
+                  <a:srgbClr val="64748B"/>
+                </a:solidFill>
+              </a:rPr>
+              <a:t>Contribution / screenshot</a:t>
+            </a:r>
+          </a:p>
+        </p:txBody>
+      </p:sp>
+      <p:sp>
+        <p:nvSpPr>
+          <p:cNvPr id="100089" name="TextBox 7"/>
+          <p:cNvSpPr/>
+          <p:nvPr/>
+        </p:nvSpPr>
+        <p:spPr>
+          <a:xfrm>
+            <a:off x="5806440" y="3063240"/>
+            <a:ext cx="2148840" cy="1371600"/>
+          </a:xfrm>
+          <a:prstGeom prst="roundRect">
+            <a:avLst/>
+          </a:prstGeom>
+          <a:solidFill>
+            <a:srgbClr val="F8FAFC"/>
+          </a:solidFill>
+          <a:ln>
+            <a:noFill/>
+          </a:ln>
+        </p:spPr>
+        <p:txBody>
+          <a:bodyPr lIns="73152" tIns="73152" rIns="73152" bIns="73152"/>
+          <a:lstStyle/>
+          <a:p>
+            <a:pPr algn="ctr"/>
+            <a:r>
+              <a:rPr lang="en-US" sz="1500" b="0">
+                <a:solidFill>
+                  <a:srgbClr val="64748B"/>
+                </a:solidFill>
+              </a:rPr>
+              <a:t>Member 4</a:t>
+            </a:r>
+          </a:p>
+          <a:p>
+            <a:pPr algn="ctr"/>
+            <a:r>
+              <a:rPr lang="en-US" sz="1500" b="0">
+                <a:solidFill>
+                  <a:srgbClr val="64748B"/>
+                </a:solidFill>
+              </a:rPr>
+              <a:t>Name / Roll No.</a:t>
+            </a:r>
+          </a:p>
+          <a:p>
+            <a:pPr algn="ctr"/>
+            <a:r>
+              <a:rPr lang="en-US" sz="1500" b="0">
+                <a:solidFill>
+                  <a:srgbClr val="64748B"/>
+                </a:solidFill>
+              </a:rPr>
+              <a:t>Contribution / screenshot</a:t>
+            </a:r>
+          </a:p>
+        </p:txBody>
+      </p:sp>
+      <p:sp>
+        <p:nvSpPr>
+          <p:cNvPr id="100090" name="TextBox 8"/>
+          <p:cNvSpPr/>
+          <p:nvPr/>
+        </p:nvSpPr>
+        <p:spPr>
+          <a:xfrm>
+            <a:off x="914400" y="5074920"/>
+            <a:ext cx="6812280" cy="502920"/>
+          </a:xfrm>
+          <a:prstGeom prst="rect">
+            <a:avLst/>
+          </a:prstGeom>
+          <a:noFill/>
+          <a:ln>
+            <a:noFill/>
+          </a:ln>
+        </p:spPr>
+        <p:txBody>
+          <a:bodyPr lIns="73152" tIns="73152" rIns="73152" bIns="73152"/>
+          <a:lstStyle/>
+          <a:p>
+            <a:pPr algn="ctr"/>
+            <a:r>
+              <a:rPr lang="en-US" sz="1400" b="0">
+                <a:solidFill>
+                  <a:srgbClr val="64748B"/>
+                </a:solidFill>
+              </a:rPr>
+              <a:t>Replace each placeholder card with the teammate's project screenshot when available.</a:t>
+            </a:r>
+          </a:p>
+        </p:txBody>
+      </p:sp>
     </p:spTree>
   </p:cSld>
   <p:clrMapOvr>
@@ -8860,7 +10235,7 @@
 </file>
 
 <file path=ppt/slides/slide14.xml><?xml version="1.0" encoding="utf-8"?>
-<p:sld xmlns:a="http://schemas.openxmlformats.org/drawingml/2006/main" xmlns:r="http://schemas.openxmlformats.org/officeDocument/2006/relationships" xmlns:p="http://schemas.openxmlformats.org/presentationml/2006/main">
+<p:sld xmlns:mc="http://schemas.openxmlformats.org/markup-compatibility/2006" xmlns:mv="urn:schemas-microsoft-com:mac:vml" xmlns:c="http://schemas.openxmlformats.org/drawingml/2006/chart" xmlns:dgm="http://schemas.openxmlformats.org/drawingml/2006/diagram" xmlns:o="urn:schemas-microsoft-com:office:office" xmlns:v="urn:schemas-microsoft-com:vml" xmlns:pvml="urn:schemas-microsoft-com:office:powerpoint" xmlns:com="http://schemas.openxmlformats.org/drawingml/2006/compatibility" xmlns:p14="http://schemas.microsoft.com/office/powerpoint/2010/main" xmlns:p15="http://schemas.microsoft.com/office/powerpoint/2012/main" xmlns:ahyp="http://schemas.microsoft.com/office/drawing/2018/hyperlinkcolor" xmlns:a="http://schemas.openxmlformats.org/drawingml/2006/main" xmlns:r="http://schemas.openxmlformats.org/officeDocument/2006/relationships" xmlns:p="http://schemas.openxmlformats.org/presentationml/2006/main">
   <p:cSld>
     <p:spTree>
       <p:nvGrpSpPr>
@@ -8952,12 +10327,12 @@
                 <a:hlinkClick r:id="rId4">
                   <a:extLst>
                     <a:ext uri="{A12FA001-AC4F-418D-AE19-62706E023703}">
-                      <ahyp:hlinkClr xmlns="" xmlns:mc="http://schemas.openxmlformats.org/markup-compatibility/2006" xmlns:mv="urn:schemas-microsoft-com:mac:vml" xmlns:c="http://schemas.openxmlformats.org/drawingml/2006/chart" xmlns:dgm="http://schemas.openxmlformats.org/drawingml/2006/diagram" xmlns:o="urn:schemas-microsoft-com:office:office" xmlns:v="urn:schemas-microsoft-com:vml" xmlns:pvml="urn:schemas-microsoft-com:office:powerpoint" xmlns:com="http://schemas.openxmlformats.org/drawingml/2006/compatibility" xmlns:p14="http://schemas.microsoft.com/office/powerpoint/2010/main" xmlns:p15="http://schemas.microsoft.com/office/powerpoint/2012/main" xmlns:ahyp="http://schemas.microsoft.com/office/drawing/2018/hyperlinkcolor" val="tx"/>
+                      <ahyp:hlinkClr xmlns:mc="http://schemas.openxmlformats.org/markup-compatibility/2006" xmlns:mv="urn:schemas-microsoft-com:mac:vml" xmlns:c="http://schemas.openxmlformats.org/drawingml/2006/chart" xmlns:dgm="http://schemas.openxmlformats.org/drawingml/2006/diagram" xmlns:o="urn:schemas-microsoft-com:office:office" xmlns:v="urn:schemas-microsoft-com:vml" xmlns:pvml="urn:schemas-microsoft-com:office:powerpoint" xmlns:com="http://schemas.openxmlformats.org/drawingml/2006/compatibility" xmlns:p14="http://schemas.microsoft.com/office/powerpoint/2010/main" xmlns:p15="http://schemas.microsoft.com/office/powerpoint/2012/main" xmlns:ahyp="http://schemas.microsoft.com/office/drawing/2018/hyperlinkcolor" val="tx"/>
                     </a:ext>
                   </a:extLst>
                 </a:hlinkClick>
               </a:rPr>
-              <a:t>www.slrtce.in</a:t>
+              <a:t>VyaparMarg</a:t>
             </a:r>
             <a:endParaRPr sz="1400">
               <a:latin typeface="Times New Roman"/>
@@ -9015,7 +10390,7 @@
                 <a:cs typeface="Times New Roman"/>
                 <a:sym typeface="Times New Roman"/>
               </a:rPr>
-              <a:t>10</a:t>
+              <a:t>Thank you</a:t>
             </a:r>
             <a:endParaRPr sz="1400">
               <a:latin typeface="Times New Roman"/>
@@ -9132,6 +10507,78 @@
           </p:txBody>
         </p:sp>
       </p:grpSp>
+      <p:sp>
+        <p:nvSpPr>
+          <p:cNvPr id="100091" name="TextBox 3"/>
+          <p:cNvSpPr/>
+          <p:nvPr/>
+        </p:nvSpPr>
+        <p:spPr>
+          <a:xfrm>
+            <a:off x="2560320" y="2011680"/>
+            <a:ext cx="3291840" cy="777240"/>
+          </a:xfrm>
+          <a:prstGeom prst="roundRect">
+            <a:avLst/>
+          </a:prstGeom>
+          <a:solidFill>
+            <a:srgbClr val="145DA0"/>
+          </a:solidFill>
+          <a:ln>
+            <a:noFill/>
+          </a:ln>
+        </p:spPr>
+        <p:txBody>
+          <a:bodyPr lIns="73152" tIns="73152" rIns="73152" bIns="73152"/>
+          <a:lstStyle/>
+          <a:p>
+            <a:pPr algn="ctr"/>
+            <a:r>
+              <a:rPr lang="en-US" sz="3000" b="1">
+                <a:solidFill>
+                  <a:srgbClr val="FFFFFF"/>
+                </a:solidFill>
+              </a:rPr>
+              <a:t>Questions?</a:t>
+            </a:r>
+          </a:p>
+        </p:txBody>
+      </p:sp>
+      <p:sp>
+        <p:nvSpPr>
+          <p:cNvPr id="100092" name="TextBox 4"/>
+          <p:cNvSpPr/>
+          <p:nvPr/>
+        </p:nvSpPr>
+        <p:spPr>
+          <a:xfrm>
+            <a:off x="1828800" y="3063240"/>
+            <a:ext cx="4754880" cy="502920"/>
+          </a:xfrm>
+          <a:prstGeom prst="rect">
+            <a:avLst/>
+          </a:prstGeom>
+          <a:noFill/>
+          <a:ln>
+            <a:noFill/>
+          </a:ln>
+        </p:spPr>
+        <p:txBody>
+          <a:bodyPr lIns="73152" tIns="73152" rIns="73152" bIns="73152"/>
+          <a:lstStyle/>
+          <a:p>
+            <a:pPr algn="ctr"/>
+            <a:r>
+              <a:rPr lang="en-US" sz="1800" b="0">
+                <a:solidFill>
+                  <a:srgbClr val="172B4D"/>
+                </a:solidFill>
+              </a:rPr>
+              <a:t>A trusted digital companion for rural entrepreneurs</a:t>
+            </a:r>
+          </a:p>
+        </p:txBody>
+      </p:sp>
     </p:spTree>
   </p:cSld>
   <p:clrMapOvr>
@@ -10036,6 +11483,296 @@
           </a:p>
         </p:txBody>
       </p:sp>
+      <p:sp>
+        <p:nvSpPr>
+          <p:cNvPr id="100008" name="TextBox 3"/>
+          <p:cNvSpPr/>
+          <p:nvPr/>
+        </p:nvSpPr>
+        <p:spPr>
+          <a:xfrm>
+            <a:off x="685800" y="2331720"/>
+            <a:ext cx="1188720" cy="548640"/>
+          </a:xfrm>
+          <a:prstGeom prst="roundRect">
+            <a:avLst/>
+          </a:prstGeom>
+          <a:solidFill>
+            <a:srgbClr val="145DA0"/>
+          </a:solidFill>
+          <a:ln>
+            <a:noFill/>
+          </a:ln>
+        </p:spPr>
+        <p:txBody>
+          <a:bodyPr lIns="73152" tIns="73152" rIns="73152" bIns="73152"/>
+          <a:lstStyle/>
+          <a:p>
+            <a:pPr algn="ctr"/>
+            <a:r>
+              <a:rPr lang="en-US" sz="1800" b="1">
+                <a:solidFill>
+                  <a:srgbClr val="FFFFFF"/>
+                </a:solidFill>
+              </a:rPr>
+              <a:t>Need</a:t>
+            </a:r>
+          </a:p>
+        </p:txBody>
+      </p:sp>
+      <p:sp>
+        <p:nvSpPr>
+          <p:cNvPr id="100009" name="TextBox 4"/>
+          <p:cNvSpPr/>
+          <p:nvPr/>
+        </p:nvSpPr>
+        <p:spPr>
+          <a:xfrm>
+            <a:off x="1874520" y="2450592"/>
+            <a:ext cx="502920" cy="320040"/>
+          </a:xfrm>
+          <a:prstGeom prst="rightArrow">
+            <a:avLst/>
+          </a:prstGeom>
+          <a:noFill/>
+          <a:ln>
+            <a:noFill/>
+          </a:ln>
+        </p:spPr>
+        <p:txBody>
+          <a:bodyPr lIns="73152" tIns="73152" rIns="73152" bIns="73152"/>
+          <a:lstStyle/>
+          <a:p>
+            <a:pPr algn="ctr"/>
+            <a:r>
+              <a:rPr lang="en-US" sz="2400" b="1">
+                <a:solidFill>
+                  <a:srgbClr val="F97316"/>
+                </a:solidFill>
+              </a:rPr>
+              <a:t>&gt;</a:t>
+            </a:r>
+          </a:p>
+        </p:txBody>
+      </p:sp>
+      <p:sp>
+        <p:nvSpPr>
+          <p:cNvPr id="100010" name="TextBox 5"/>
+          <p:cNvSpPr/>
+          <p:nvPr/>
+        </p:nvSpPr>
+        <p:spPr>
+          <a:xfrm>
+            <a:off x="2468880" y="2331720"/>
+            <a:ext cx="1325880" cy="548640"/>
+          </a:xfrm>
+          <a:prstGeom prst="roundRect">
+            <a:avLst/>
+          </a:prstGeom>
+          <a:solidFill>
+            <a:srgbClr val="F97316"/>
+          </a:solidFill>
+          <a:ln>
+            <a:noFill/>
+          </a:ln>
+        </p:spPr>
+        <p:txBody>
+          <a:bodyPr lIns="73152" tIns="73152" rIns="73152" bIns="73152"/>
+          <a:lstStyle/>
+          <a:p>
+            <a:pPr algn="ctr"/>
+            <a:r>
+              <a:rPr lang="en-US" sz="1800" b="1">
+                <a:solidFill>
+                  <a:srgbClr val="FFFFFF"/>
+                </a:solidFill>
+              </a:rPr>
+              <a:t>Understand</a:t>
+            </a:r>
+          </a:p>
+        </p:txBody>
+      </p:sp>
+      <p:sp>
+        <p:nvSpPr>
+          <p:cNvPr id="100011" name="TextBox 6"/>
+          <p:cNvSpPr/>
+          <p:nvPr/>
+        </p:nvSpPr>
+        <p:spPr>
+          <a:xfrm>
+            <a:off x="3803904" y="2450592"/>
+            <a:ext cx="502920" cy="320040"/>
+          </a:xfrm>
+          <a:prstGeom prst="rightArrow">
+            <a:avLst/>
+          </a:prstGeom>
+          <a:noFill/>
+          <a:ln>
+            <a:noFill/>
+          </a:ln>
+        </p:spPr>
+        <p:txBody>
+          <a:bodyPr lIns="73152" tIns="73152" rIns="73152" bIns="73152"/>
+          <a:lstStyle/>
+          <a:p>
+            <a:pPr algn="ctr"/>
+            <a:r>
+              <a:rPr lang="en-US" sz="2400" b="1">
+                <a:solidFill>
+                  <a:srgbClr val="F97316"/>
+                </a:solidFill>
+              </a:rPr>
+              <a:t>&gt;</a:t>
+            </a:r>
+          </a:p>
+        </p:txBody>
+      </p:sp>
+      <p:sp>
+        <p:nvSpPr>
+          <p:cNvPr id="100012" name="TextBox 7"/>
+          <p:cNvSpPr/>
+          <p:nvPr/>
+        </p:nvSpPr>
+        <p:spPr>
+          <a:xfrm>
+            <a:off x="4389120" y="2331720"/>
+            <a:ext cx="1234440" cy="548640"/>
+          </a:xfrm>
+          <a:prstGeom prst="roundRect">
+            <a:avLst/>
+          </a:prstGeom>
+          <a:solidFill>
+            <a:srgbClr val="138A5E"/>
+          </a:solidFill>
+          <a:ln>
+            <a:noFill/>
+          </a:ln>
+        </p:spPr>
+        <p:txBody>
+          <a:bodyPr lIns="73152" tIns="73152" rIns="73152" bIns="73152"/>
+          <a:lstStyle/>
+          <a:p>
+            <a:pPr algn="ctr"/>
+            <a:r>
+              <a:rPr lang="en-US" sz="1800" b="1">
+                <a:solidFill>
+                  <a:srgbClr val="FFFFFF"/>
+                </a:solidFill>
+              </a:rPr>
+              <a:t>Validate</a:t>
+            </a:r>
+          </a:p>
+        </p:txBody>
+      </p:sp>
+      <p:sp>
+        <p:nvSpPr>
+          <p:cNvPr id="100013" name="TextBox 8"/>
+          <p:cNvSpPr/>
+          <p:nvPr/>
+        </p:nvSpPr>
+        <p:spPr>
+          <a:xfrm>
+            <a:off x="5577840" y="2450592"/>
+            <a:ext cx="502920" cy="320040"/>
+          </a:xfrm>
+          <a:prstGeom prst="rightArrow">
+            <a:avLst/>
+          </a:prstGeom>
+          <a:noFill/>
+          <a:ln>
+            <a:noFill/>
+          </a:ln>
+        </p:spPr>
+        <p:txBody>
+          <a:bodyPr lIns="73152" tIns="73152" rIns="73152" bIns="73152"/>
+          <a:lstStyle/>
+          <a:p>
+            <a:pPr algn="ctr"/>
+            <a:r>
+              <a:rPr lang="en-US" sz="2400" b="1">
+                <a:solidFill>
+                  <a:srgbClr val="F97316"/>
+                </a:solidFill>
+              </a:rPr>
+              <a:t>&gt;</a:t>
+            </a:r>
+          </a:p>
+        </p:txBody>
+      </p:sp>
+      <p:sp>
+        <p:nvSpPr>
+          <p:cNvPr id="100014" name="TextBox 9"/>
+          <p:cNvSpPr/>
+          <p:nvPr/>
+        </p:nvSpPr>
+        <p:spPr>
+          <a:xfrm>
+            <a:off x="6144768" y="2331720"/>
+            <a:ext cx="1097280" cy="548640"/>
+          </a:xfrm>
+          <a:prstGeom prst="roundRect">
+            <a:avLst/>
+          </a:prstGeom>
+          <a:solidFill>
+            <a:srgbClr val="7C3AED"/>
+          </a:solidFill>
+          <a:ln>
+            <a:noFill/>
+          </a:ln>
+        </p:spPr>
+        <p:txBody>
+          <a:bodyPr lIns="73152" tIns="73152" rIns="73152" bIns="73152"/>
+          <a:lstStyle/>
+          <a:p>
+            <a:pPr algn="ctr"/>
+            <a:r>
+              <a:rPr lang="en-US" sz="1800" b="1">
+                <a:solidFill>
+                  <a:srgbClr val="FFFFFF"/>
+                </a:solidFill>
+              </a:rPr>
+              <a:t>Apply</a:t>
+            </a:r>
+          </a:p>
+        </p:txBody>
+      </p:sp>
+      <p:sp>
+        <p:nvSpPr>
+          <p:cNvPr id="100015" name="TextBox 10"/>
+          <p:cNvSpPr/>
+          <p:nvPr/>
+        </p:nvSpPr>
+        <p:spPr>
+          <a:xfrm>
+            <a:off x="1143000" y="3840480"/>
+            <a:ext cx="6629400" cy="640080"/>
+          </a:xfrm>
+          <a:prstGeom prst="roundRect">
+            <a:avLst/>
+          </a:prstGeom>
+          <a:solidFill>
+            <a:srgbClr val="E8F1FF"/>
+          </a:solidFill>
+          <a:ln>
+            <a:noFill/>
+          </a:ln>
+        </p:spPr>
+        <p:txBody>
+          <a:bodyPr lIns="73152" tIns="73152" rIns="73152" bIns="73152"/>
+          <a:lstStyle/>
+          <a:p>
+            <a:pPr algn="ctr"/>
+            <a:r>
+              <a:rPr lang="en-US" sz="2000" b="1">
+                <a:solidFill>
+                  <a:srgbClr val="0F2747"/>
+                </a:solidFill>
+              </a:rPr>
+              <a:t>VyaparMarg connects these steps through one assistant-led, explainable journey.</a:t>
+            </a:r>
+          </a:p>
+        </p:txBody>
+      </p:sp>
     </p:spTree>
   </p:cSld>
   <p:clrMapOvr>
@@ -10107,6 +11844,102 @@
           </a:p>
         </p:txBody>
       </p:sp>
+      <p:sp>
+        <p:nvSpPr>
+          <p:cNvPr id="100016" name="TextBox 2"/>
+          <p:cNvSpPr/>
+          <p:nvPr/>
+        </p:nvSpPr>
+        <p:spPr>
+          <a:xfrm>
+            <a:off x="640080" y="1325880"/>
+            <a:ext cx="3794760" cy="2560320"/>
+          </a:xfrm>
+          <a:prstGeom prst="roundRect">
+            <a:avLst/>
+          </a:prstGeom>
+          <a:solidFill>
+            <a:srgbClr val="F8FAFC"/>
+          </a:solidFill>
+          <a:ln>
+            <a:noFill/>
+          </a:ln>
+        </p:spPr>
+        <p:txBody>
+          <a:bodyPr lIns="73152" tIns="73152" rIns="73152" bIns="73152"/>
+          <a:lstStyle/>
+          <a:p>
+            <a:pPr algn="l"/>
+            <a:r>
+              <a:rPr lang="en-US" sz="1600" b="0">
+                <a:solidFill>
+                  <a:srgbClr val="172B4D"/>
+                </a:solidFill>
+              </a:rPr>
+              <a:t>VyaparMarg is a mobile-first rural business assistant that combines multilingual conversation, structured business profiles and deterministic scheme rules. It recommends relevant programmes, explains why they match, identifies missing information and guides the user through an application plan.</a:t>
+            </a:r>
+          </a:p>
+        </p:txBody>
+      </p:sp>
+      <p:pic>
+        <p:nvPicPr>
+          <p:cNvPr id="100017" name="Picture 1" descr="VyaparMarg mobile assistant dashboard concept"/>
+          <p:cNvPicPr>
+            <a:picLocks noChangeAspect="1"/>
+          </p:cNvPicPr>
+          <p:nvPr/>
+        </p:nvPicPr>
+        <p:blipFill>
+          <a:blip r:embed="R75e9e602c9934b95"/>
+          <a:stretch>
+            <a:fillRect/>
+          </a:stretch>
+        </p:blipFill>
+        <p:spPr>
+          <a:xfrm>
+            <a:off x="4800600" y="1097280"/>
+            <a:ext cx="2331720" cy="4526280"/>
+          </a:xfrm>
+          <a:prstGeom prst="rect">
+            <a:avLst/>
+          </a:prstGeom>
+        </p:spPr>
+      </p:pic>
+      <p:sp>
+        <p:nvSpPr>
+          <p:cNvPr id="100018" name="TextBox 3"/>
+          <p:cNvSpPr/>
+          <p:nvPr/>
+        </p:nvSpPr>
+        <p:spPr>
+          <a:xfrm>
+            <a:off x="4663440" y="5715000"/>
+            <a:ext cx="2743200" cy="365760"/>
+          </a:xfrm>
+          <a:prstGeom prst="rect">
+            <a:avLst/>
+          </a:prstGeom>
+          <a:noFill/>
+          <a:ln>
+            <a:noFill/>
+          </a:ln>
+        </p:spPr>
+        <p:txBody>
+          <a:bodyPr lIns="73152" tIns="73152" rIns="73152" bIns="73152"/>
+          <a:lstStyle/>
+          <a:p>
+            <a:pPr algn="ctr"/>
+            <a:r>
+              <a:rPr lang="en-US" sz="1100" b="0">
+                <a:solidFill>
+                  <a:srgbClr val="64748B"/>
+                </a:solidFill>
+              </a:rPr>
+              <a:t>Application image: mobile assistant dashboard</a:t>
+            </a:r>
+          </a:p>
+        </p:txBody>
+      </p:sp>
     </p:spTree>
   </p:cSld>
   <p:clrMapOvr>
@@ -10175,6 +12008,331 @@
               <a:t>Introduction</a:t>
             </a:r>
             <a:endParaRPr/>
+          </a:p>
+        </p:txBody>
+      </p:sp>
+      <p:sp>
+        <p:nvSpPr>
+          <p:cNvPr id="100019" name="TextBox 2"/>
+          <p:cNvSpPr/>
+          <p:nvPr/>
+        </p:nvSpPr>
+        <p:spPr>
+          <a:xfrm>
+            <a:off x="640080" y="1280160"/>
+            <a:ext cx="3383280" cy="292608"/>
+          </a:xfrm>
+          <a:prstGeom prst="roundRect">
+            <a:avLst/>
+          </a:prstGeom>
+          <a:solidFill>
+            <a:srgbClr val="EEF5FF"/>
+          </a:solidFill>
+          <a:ln>
+            <a:noFill/>
+          </a:ln>
+        </p:spPr>
+        <p:txBody>
+          <a:bodyPr lIns="73152" tIns="73152" rIns="73152" bIns="73152"/>
+          <a:lstStyle/>
+          <a:p>
+            <a:pPr algn="l"/>
+            <a:r>
+              <a:rPr lang="en-US" sz="1700" b="1">
+                <a:solidFill>
+                  <a:srgbClr val="145DA0"/>
+                </a:solidFill>
+              </a:rPr>
+              <a:t>Voice-first access</a:t>
+            </a:r>
+          </a:p>
+        </p:txBody>
+      </p:sp>
+      <p:sp>
+        <p:nvSpPr>
+          <p:cNvPr id="100020" name="TextBox 3"/>
+          <p:cNvSpPr/>
+          <p:nvPr/>
+        </p:nvSpPr>
+        <p:spPr>
+          <a:xfrm>
+            <a:off x="640080" y="1591056"/>
+            <a:ext cx="3383280" cy="795528"/>
+          </a:xfrm>
+          <a:prstGeom prst="rect">
+            <a:avLst/>
+          </a:prstGeom>
+          <a:noFill/>
+          <a:ln>
+            <a:noFill/>
+          </a:ln>
+        </p:spPr>
+        <p:txBody>
+          <a:bodyPr lIns="73152" tIns="73152" rIns="73152" bIns="73152"/>
+          <a:lstStyle/>
+          <a:p>
+            <a:pPr algn="l"/>
+            <a:r>
+              <a:rPr lang="en-US" sz="1200" b="0">
+                <a:solidFill>
+                  <a:srgbClr val="344563"/>
+                </a:solidFill>
+              </a:rPr>
+              <a:t>Ask in Marathi, Hindi, Hinglish or English.</a:t>
+            </a:r>
+          </a:p>
+        </p:txBody>
+      </p:sp>
+      <p:sp>
+        <p:nvSpPr>
+          <p:cNvPr id="100021" name="TextBox 4"/>
+          <p:cNvSpPr/>
+          <p:nvPr/>
+        </p:nvSpPr>
+        <p:spPr>
+          <a:xfrm>
+            <a:off x="4434840" y="1280160"/>
+            <a:ext cx="3383280" cy="292608"/>
+          </a:xfrm>
+          <a:prstGeom prst="roundRect">
+            <a:avLst/>
+          </a:prstGeom>
+          <a:solidFill>
+            <a:srgbClr val="FFF4E8"/>
+          </a:solidFill>
+          <a:ln>
+            <a:noFill/>
+          </a:ln>
+        </p:spPr>
+        <p:txBody>
+          <a:bodyPr lIns="73152" tIns="73152" rIns="73152" bIns="73152"/>
+          <a:lstStyle/>
+          <a:p>
+            <a:pPr algn="l"/>
+            <a:r>
+              <a:rPr lang="en-US" sz="1700" b="1">
+                <a:solidFill>
+                  <a:srgbClr val="F97316"/>
+                </a:solidFill>
+              </a:rPr>
+              <a:t>Profile-aware</a:t>
+            </a:r>
+          </a:p>
+        </p:txBody>
+      </p:sp>
+      <p:sp>
+        <p:nvSpPr>
+          <p:cNvPr id="100022" name="TextBox 5"/>
+          <p:cNvSpPr/>
+          <p:nvPr/>
+        </p:nvSpPr>
+        <p:spPr>
+          <a:xfrm>
+            <a:off x="4434840" y="1591056"/>
+            <a:ext cx="3383280" cy="795528"/>
+          </a:xfrm>
+          <a:prstGeom prst="rect">
+            <a:avLst/>
+          </a:prstGeom>
+          <a:noFill/>
+          <a:ln>
+            <a:noFill/>
+          </a:ln>
+        </p:spPr>
+        <p:txBody>
+          <a:bodyPr lIns="73152" tIns="73152" rIns="73152" bIns="73152"/>
+          <a:lstStyle/>
+          <a:p>
+            <a:pPr algn="l"/>
+            <a:r>
+              <a:rPr lang="en-US" sz="1200" b="0">
+                <a:solidFill>
+                  <a:srgbClr val="344563"/>
+                </a:solidFill>
+              </a:rPr>
+              <a:t>Recommendations use business type, location and scale.</a:t>
+            </a:r>
+          </a:p>
+        </p:txBody>
+      </p:sp>
+      <p:sp>
+        <p:nvSpPr>
+          <p:cNvPr id="100023" name="TextBox 6"/>
+          <p:cNvSpPr/>
+          <p:nvPr/>
+        </p:nvSpPr>
+        <p:spPr>
+          <a:xfrm>
+            <a:off x="640080" y="2788920"/>
+            <a:ext cx="3383280" cy="292608"/>
+          </a:xfrm>
+          <a:prstGeom prst="roundRect">
+            <a:avLst/>
+          </a:prstGeom>
+          <a:solidFill>
+            <a:srgbClr val="ECFDF3"/>
+          </a:solidFill>
+          <a:ln>
+            <a:noFill/>
+          </a:ln>
+        </p:spPr>
+        <p:txBody>
+          <a:bodyPr lIns="73152" tIns="73152" rIns="73152" bIns="73152"/>
+          <a:lstStyle/>
+          <a:p>
+            <a:pPr algn="l"/>
+            <a:r>
+              <a:rPr lang="en-US" sz="1700" b="1">
+                <a:solidFill>
+                  <a:srgbClr val="138A5E"/>
+                </a:solidFill>
+              </a:rPr>
+              <a:t>Explainable</a:t>
+            </a:r>
+          </a:p>
+        </p:txBody>
+      </p:sp>
+      <p:sp>
+        <p:nvSpPr>
+          <p:cNvPr id="100024" name="TextBox 7"/>
+          <p:cNvSpPr/>
+          <p:nvPr/>
+        </p:nvSpPr>
+        <p:spPr>
+          <a:xfrm>
+            <a:off x="640080" y="3099816"/>
+            <a:ext cx="3383280" cy="795528"/>
+          </a:xfrm>
+          <a:prstGeom prst="rect">
+            <a:avLst/>
+          </a:prstGeom>
+          <a:noFill/>
+          <a:ln>
+            <a:noFill/>
+          </a:ln>
+        </p:spPr>
+        <p:txBody>
+          <a:bodyPr lIns="73152" tIns="73152" rIns="73152" bIns="73152"/>
+          <a:lstStyle/>
+          <a:p>
+            <a:pPr algn="l"/>
+            <a:r>
+              <a:rPr lang="en-US" sz="1200" b="0">
+                <a:solidFill>
+                  <a:srgbClr val="344563"/>
+                </a:solidFill>
+              </a:rPr>
+              <a:t>Every recommendation includes reasons and missing requirements.</a:t>
+            </a:r>
+          </a:p>
+        </p:txBody>
+      </p:sp>
+      <p:sp>
+        <p:nvSpPr>
+          <p:cNvPr id="100025" name="TextBox 8"/>
+          <p:cNvSpPr/>
+          <p:nvPr/>
+        </p:nvSpPr>
+        <p:spPr>
+          <a:xfrm>
+            <a:off x="4434840" y="2788920"/>
+            <a:ext cx="3383280" cy="292608"/>
+          </a:xfrm>
+          <a:prstGeom prst="roundRect">
+            <a:avLst/>
+          </a:prstGeom>
+          <a:solidFill>
+            <a:srgbClr val="F5F3FF"/>
+          </a:solidFill>
+          <a:ln>
+            <a:noFill/>
+          </a:ln>
+        </p:spPr>
+        <p:txBody>
+          <a:bodyPr lIns="73152" tIns="73152" rIns="73152" bIns="73152"/>
+          <a:lstStyle/>
+          <a:p>
+            <a:pPr algn="l"/>
+            <a:r>
+              <a:rPr lang="en-US" sz="1700" b="1">
+                <a:solidFill>
+                  <a:srgbClr val="7C3AED"/>
+                </a:solidFill>
+              </a:rPr>
+              <a:t>Actionable</a:t>
+            </a:r>
+          </a:p>
+        </p:txBody>
+      </p:sp>
+      <p:sp>
+        <p:nvSpPr>
+          <p:cNvPr id="100026" name="TextBox 9"/>
+          <p:cNvSpPr/>
+          <p:nvPr/>
+        </p:nvSpPr>
+        <p:spPr>
+          <a:xfrm>
+            <a:off x="4434840" y="3099816"/>
+            <a:ext cx="3383280" cy="795528"/>
+          </a:xfrm>
+          <a:prstGeom prst="rect">
+            <a:avLst/>
+          </a:prstGeom>
+          <a:noFill/>
+          <a:ln>
+            <a:noFill/>
+          </a:ln>
+        </p:spPr>
+        <p:txBody>
+          <a:bodyPr lIns="73152" tIns="73152" rIns="73152" bIns="73152"/>
+          <a:lstStyle/>
+          <a:p>
+            <a:pPr algn="l"/>
+            <a:r>
+              <a:rPr lang="en-US" sz="1200" b="0">
+                <a:solidFill>
+                  <a:srgbClr val="344563"/>
+                </a:solidFill>
+              </a:rPr>
+              <a:t>Move from discovery to a planned application with progress.</a:t>
+            </a:r>
+          </a:p>
+        </p:txBody>
+      </p:sp>
+      <p:sp>
+        <p:nvSpPr>
+          <p:cNvPr id="100027" name="TextBox 10"/>
+          <p:cNvSpPr/>
+          <p:nvPr/>
+        </p:nvSpPr>
+        <p:spPr>
+          <a:xfrm>
+            <a:off x="914400" y="4800600"/>
+            <a:ext cx="6903720" cy="594360"/>
+          </a:xfrm>
+          <a:prstGeom prst="roundRect">
+            <a:avLst/>
+          </a:prstGeom>
+          <a:solidFill>
+            <a:srgbClr val="FFF7ED"/>
+          </a:solidFill>
+          <a:ln>
+            <a:noFill/>
+          </a:ln>
+        </p:spPr>
+        <p:txBody>
+          <a:bodyPr lIns="73152" tIns="73152" rIns="73152" bIns="73152"/>
+          <a:lstStyle/>
+          <a:p>
+            <a:pPr algn="ctr"/>
+            <a:r>
+              <a:rPr lang="en-US" sz="1800" b="1">
+                <a:solidFill>
+                  <a:srgbClr val="0F2747"/>
+                </a:solidFill>
+              </a:rPr>
+              <a:t>Design principle: AI explains; structured data and deterministic rules decide eligibility.</a:t>
+            </a:r>
           </a:p>
         </p:txBody>
       </p:sp>
@@ -12553,6 +14711,510 @@
           </a:p>
         </p:txBody>
       </p:sp>
+      <p:sp>
+        <p:nvSpPr>
+          <p:cNvPr id="100028" name="TextBox 2"/>
+          <p:cNvSpPr/>
+          <p:nvPr/>
+        </p:nvSpPr>
+        <p:spPr>
+          <a:xfrm>
+            <a:off x="640080" y="1234440"/>
+            <a:ext cx="2286000" cy="411480"/>
+          </a:xfrm>
+          <a:prstGeom prst="rect">
+            <a:avLst/>
+          </a:prstGeom>
+          <a:noFill/>
+          <a:ln>
+            <a:noFill/>
+          </a:ln>
+        </p:spPr>
+        <p:txBody>
+          <a:bodyPr lIns="73152" tIns="73152" rIns="73152" bIns="73152"/>
+          <a:lstStyle/>
+          <a:p>
+            <a:pPr algn="l"/>
+            <a:r>
+              <a:rPr lang="en-US" sz="1800" b="1">
+                <a:solidFill>
+                  <a:srgbClr val="145DA0"/>
+                </a:solidFill>
+              </a:rPr>
+              <a:t>Current journey</a:t>
+            </a:r>
+          </a:p>
+        </p:txBody>
+      </p:sp>
+      <p:sp>
+        <p:nvSpPr>
+          <p:cNvPr id="100029" name="TextBox 3"/>
+          <p:cNvSpPr/>
+          <p:nvPr/>
+        </p:nvSpPr>
+        <p:spPr>
+          <a:xfrm>
+            <a:off x="640080" y="1828800"/>
+            <a:ext cx="1325880" cy="548640"/>
+          </a:xfrm>
+          <a:prstGeom prst="roundRect">
+            <a:avLst/>
+          </a:prstGeom>
+          <a:solidFill>
+            <a:srgbClr val="145DA0"/>
+          </a:solidFill>
+          <a:ln>
+            <a:noFill/>
+          </a:ln>
+        </p:spPr>
+        <p:txBody>
+          <a:bodyPr lIns="73152" tIns="73152" rIns="73152" bIns="73152"/>
+          <a:lstStyle/>
+          <a:p>
+            <a:pPr algn="ctr"/>
+            <a:r>
+              <a:rPr lang="en-US" sz="1500" b="1">
+                <a:solidFill>
+                  <a:srgbClr val="FFFFFF"/>
+                </a:solidFill>
+              </a:rPr>
+              <a:t>Search web</a:t>
+            </a:r>
+          </a:p>
+        </p:txBody>
+      </p:sp>
+      <p:sp>
+        <p:nvSpPr>
+          <p:cNvPr id="100030" name="TextBox 4"/>
+          <p:cNvSpPr/>
+          <p:nvPr/>
+        </p:nvSpPr>
+        <p:spPr>
+          <a:xfrm>
+            <a:off x="2011680" y="1938528"/>
+            <a:ext cx="502920" cy="320040"/>
+          </a:xfrm>
+          <a:prstGeom prst="rightArrow">
+            <a:avLst/>
+          </a:prstGeom>
+          <a:noFill/>
+          <a:ln>
+            <a:noFill/>
+          </a:ln>
+        </p:spPr>
+        <p:txBody>
+          <a:bodyPr lIns="73152" tIns="73152" rIns="73152" bIns="73152"/>
+          <a:lstStyle/>
+          <a:p>
+            <a:pPr algn="ctr"/>
+            <a:r>
+              <a:rPr lang="en-US" sz="2400" b="1">
+                <a:solidFill>
+                  <a:srgbClr val="F97316"/>
+                </a:solidFill>
+              </a:rPr>
+              <a:t>&gt;</a:t>
+            </a:r>
+          </a:p>
+        </p:txBody>
+      </p:sp>
+      <p:sp>
+        <p:nvSpPr>
+          <p:cNvPr id="100031" name="TextBox 5"/>
+          <p:cNvSpPr/>
+          <p:nvPr/>
+        </p:nvSpPr>
+        <p:spPr>
+          <a:xfrm>
+            <a:off x="2606040" y="1828800"/>
+            <a:ext cx="1325880" cy="548640"/>
+          </a:xfrm>
+          <a:prstGeom prst="roundRect">
+            <a:avLst/>
+          </a:prstGeom>
+          <a:solidFill>
+            <a:srgbClr val="F97316"/>
+          </a:solidFill>
+          <a:ln>
+            <a:noFill/>
+          </a:ln>
+        </p:spPr>
+        <p:txBody>
+          <a:bodyPr lIns="73152" tIns="73152" rIns="73152" bIns="73152"/>
+          <a:lstStyle/>
+          <a:p>
+            <a:pPr algn="ctr"/>
+            <a:r>
+              <a:rPr lang="en-US" sz="1500" b="1">
+                <a:solidFill>
+                  <a:srgbClr val="FFFFFF"/>
+                </a:solidFill>
+              </a:rPr>
+              <a:t>Read PDFs</a:t>
+            </a:r>
+          </a:p>
+        </p:txBody>
+      </p:sp>
+      <p:sp>
+        <p:nvSpPr>
+          <p:cNvPr id="100032" name="TextBox 6"/>
+          <p:cNvSpPr/>
+          <p:nvPr/>
+        </p:nvSpPr>
+        <p:spPr>
+          <a:xfrm>
+            <a:off x="3977640" y="1938528"/>
+            <a:ext cx="502920" cy="320040"/>
+          </a:xfrm>
+          <a:prstGeom prst="rightArrow">
+            <a:avLst/>
+          </a:prstGeom>
+          <a:noFill/>
+          <a:ln>
+            <a:noFill/>
+          </a:ln>
+        </p:spPr>
+        <p:txBody>
+          <a:bodyPr lIns="73152" tIns="73152" rIns="73152" bIns="73152"/>
+          <a:lstStyle/>
+          <a:p>
+            <a:pPr algn="ctr"/>
+            <a:r>
+              <a:rPr lang="en-US" sz="2400" b="1">
+                <a:solidFill>
+                  <a:srgbClr val="F97316"/>
+                </a:solidFill>
+              </a:rPr>
+              <a:t>&gt;</a:t>
+            </a:r>
+          </a:p>
+        </p:txBody>
+      </p:sp>
+      <p:sp>
+        <p:nvSpPr>
+          <p:cNvPr id="100033" name="TextBox 7"/>
+          <p:cNvSpPr/>
+          <p:nvPr/>
+        </p:nvSpPr>
+        <p:spPr>
+          <a:xfrm>
+            <a:off x="4572000" y="1828800"/>
+            <a:ext cx="1325880" cy="548640"/>
+          </a:xfrm>
+          <a:prstGeom prst="roundRect">
+            <a:avLst/>
+          </a:prstGeom>
+          <a:solidFill>
+            <a:srgbClr val="7C3AED"/>
+          </a:solidFill>
+          <a:ln>
+            <a:noFill/>
+          </a:ln>
+        </p:spPr>
+        <p:txBody>
+          <a:bodyPr lIns="73152" tIns="73152" rIns="73152" bIns="73152"/>
+          <a:lstStyle/>
+          <a:p>
+            <a:pPr algn="ctr"/>
+            <a:r>
+              <a:rPr lang="en-US" sz="1500" b="1">
+                <a:solidFill>
+                  <a:srgbClr val="FFFFFF"/>
+                </a:solidFill>
+              </a:rPr>
+              <a:t>Visit office</a:t>
+            </a:r>
+          </a:p>
+        </p:txBody>
+      </p:sp>
+      <p:sp>
+        <p:nvSpPr>
+          <p:cNvPr id="100034" name="TextBox 8"/>
+          <p:cNvSpPr/>
+          <p:nvPr/>
+        </p:nvSpPr>
+        <p:spPr>
+          <a:xfrm>
+            <a:off x="5943600" y="1938528"/>
+            <a:ext cx="502920" cy="320040"/>
+          </a:xfrm>
+          <a:prstGeom prst="rightArrow">
+            <a:avLst/>
+          </a:prstGeom>
+          <a:noFill/>
+          <a:ln>
+            <a:noFill/>
+          </a:ln>
+        </p:spPr>
+        <p:txBody>
+          <a:bodyPr lIns="73152" tIns="73152" rIns="73152" bIns="73152"/>
+          <a:lstStyle/>
+          <a:p>
+            <a:pPr algn="ctr"/>
+            <a:r>
+              <a:rPr lang="en-US" sz="2400" b="1">
+                <a:solidFill>
+                  <a:srgbClr val="F97316"/>
+                </a:solidFill>
+              </a:rPr>
+              <a:t>&gt;</a:t>
+            </a:r>
+          </a:p>
+        </p:txBody>
+      </p:sp>
+      <p:sp>
+        <p:nvSpPr>
+          <p:cNvPr id="100035" name="TextBox 9"/>
+          <p:cNvSpPr/>
+          <p:nvPr/>
+        </p:nvSpPr>
+        <p:spPr>
+          <a:xfrm>
+            <a:off x="6492240" y="1828800"/>
+            <a:ext cx="1143000" cy="548640"/>
+          </a:xfrm>
+          <a:prstGeom prst="roundRect">
+            <a:avLst/>
+          </a:prstGeom>
+          <a:solidFill>
+            <a:srgbClr val="138A5E"/>
+          </a:solidFill>
+          <a:ln>
+            <a:noFill/>
+          </a:ln>
+        </p:spPr>
+        <p:txBody>
+          <a:bodyPr lIns="73152" tIns="73152" rIns="73152" bIns="73152"/>
+          <a:lstStyle/>
+          <a:p>
+            <a:pPr algn="ctr"/>
+            <a:r>
+              <a:rPr lang="en-US" sz="1500" b="1">
+                <a:solidFill>
+                  <a:srgbClr val="FFFFFF"/>
+                </a:solidFill>
+              </a:rPr>
+              <a:t>Portal form</a:t>
+            </a:r>
+          </a:p>
+        </p:txBody>
+      </p:sp>
+      <p:sp>
+        <p:nvSpPr>
+          <p:cNvPr id="100036" name="TextBox 10"/>
+          <p:cNvSpPr/>
+          <p:nvPr/>
+        </p:nvSpPr>
+        <p:spPr>
+          <a:xfrm>
+            <a:off x="640080" y="3154680"/>
+            <a:ext cx="2331720" cy="292608"/>
+          </a:xfrm>
+          <a:prstGeom prst="roundRect">
+            <a:avLst/>
+          </a:prstGeom>
+          <a:solidFill>
+            <a:srgbClr val="FFF4E8"/>
+          </a:solidFill>
+          <a:ln>
+            <a:noFill/>
+          </a:ln>
+        </p:spPr>
+        <p:txBody>
+          <a:bodyPr lIns="73152" tIns="73152" rIns="73152" bIns="73152"/>
+          <a:lstStyle/>
+          <a:p>
+            <a:pPr algn="l"/>
+            <a:r>
+              <a:rPr lang="en-US" sz="1700" b="1">
+                <a:solidFill>
+                  <a:srgbClr val="F97316"/>
+                </a:solidFill>
+              </a:rPr>
+              <a:t>Pain point 1</a:t>
+            </a:r>
+          </a:p>
+        </p:txBody>
+      </p:sp>
+      <p:sp>
+        <p:nvSpPr>
+          <p:cNvPr id="100037" name="TextBox 11"/>
+          <p:cNvSpPr/>
+          <p:nvPr/>
+        </p:nvSpPr>
+        <p:spPr>
+          <a:xfrm>
+            <a:off x="640080" y="3465576"/>
+            <a:ext cx="2331720" cy="886968"/>
+          </a:xfrm>
+          <a:prstGeom prst="rect">
+            <a:avLst/>
+          </a:prstGeom>
+          <a:noFill/>
+          <a:ln>
+            <a:noFill/>
+          </a:ln>
+        </p:spPr>
+        <p:txBody>
+          <a:bodyPr lIns="73152" tIns="73152" rIns="73152" bIns="73152"/>
+          <a:lstStyle/>
+          <a:p>
+            <a:pPr algn="l"/>
+            <a:r>
+              <a:rPr lang="en-US" sz="1200" b="0">
+                <a:solidFill>
+                  <a:srgbClr val="344563"/>
+                </a:solidFill>
+              </a:rPr>
+              <a:t>Information is scattered across portals and documents.</a:t>
+            </a:r>
+          </a:p>
+        </p:txBody>
+      </p:sp>
+      <p:sp>
+        <p:nvSpPr>
+          <p:cNvPr id="100038" name="TextBox 12"/>
+          <p:cNvSpPr/>
+          <p:nvPr/>
+        </p:nvSpPr>
+        <p:spPr>
+          <a:xfrm>
+            <a:off x="3154680" y="3154680"/>
+            <a:ext cx="2331720" cy="292608"/>
+          </a:xfrm>
+          <a:prstGeom prst="roundRect">
+            <a:avLst/>
+          </a:prstGeom>
+          <a:solidFill>
+            <a:srgbClr val="EEF5FF"/>
+          </a:solidFill>
+          <a:ln>
+            <a:noFill/>
+          </a:ln>
+        </p:spPr>
+        <p:txBody>
+          <a:bodyPr lIns="73152" tIns="73152" rIns="73152" bIns="73152"/>
+          <a:lstStyle/>
+          <a:p>
+            <a:pPr algn="l"/>
+            <a:r>
+              <a:rPr lang="en-US" sz="1700" b="1">
+                <a:solidFill>
+                  <a:srgbClr val="145DA0"/>
+                </a:solidFill>
+              </a:rPr>
+              <a:t>Pain point 2</a:t>
+            </a:r>
+          </a:p>
+        </p:txBody>
+      </p:sp>
+      <p:sp>
+        <p:nvSpPr>
+          <p:cNvPr id="100039" name="TextBox 13"/>
+          <p:cNvSpPr/>
+          <p:nvPr/>
+        </p:nvSpPr>
+        <p:spPr>
+          <a:xfrm>
+            <a:off x="3154680" y="3465576"/>
+            <a:ext cx="2331720" cy="886968"/>
+          </a:xfrm>
+          <a:prstGeom prst="rect">
+            <a:avLst/>
+          </a:prstGeom>
+          <a:noFill/>
+          <a:ln>
+            <a:noFill/>
+          </a:ln>
+        </p:spPr>
+        <p:txBody>
+          <a:bodyPr lIns="73152" tIns="73152" rIns="73152" bIns="73152"/>
+          <a:lstStyle/>
+          <a:p>
+            <a:pPr algn="l"/>
+            <a:r>
+              <a:rPr lang="en-US" sz="1200" b="0">
+                <a:solidFill>
+                  <a:srgbClr val="344563"/>
+                </a:solidFill>
+              </a:rPr>
+              <a:t>Eligibility logic is hard to interpret without support.</a:t>
+            </a:r>
+          </a:p>
+        </p:txBody>
+      </p:sp>
+      <p:sp>
+        <p:nvSpPr>
+          <p:cNvPr id="100040" name="TextBox 14"/>
+          <p:cNvSpPr/>
+          <p:nvPr/>
+        </p:nvSpPr>
+        <p:spPr>
+          <a:xfrm>
+            <a:off x="5669280" y="3154680"/>
+            <a:ext cx="2331720" cy="292608"/>
+          </a:xfrm>
+          <a:prstGeom prst="roundRect">
+            <a:avLst/>
+          </a:prstGeom>
+          <a:solidFill>
+            <a:srgbClr val="ECFDF3"/>
+          </a:solidFill>
+          <a:ln>
+            <a:noFill/>
+          </a:ln>
+        </p:spPr>
+        <p:txBody>
+          <a:bodyPr lIns="73152" tIns="73152" rIns="73152" bIns="73152"/>
+          <a:lstStyle/>
+          <a:p>
+            <a:pPr algn="l"/>
+            <a:r>
+              <a:rPr lang="en-US" sz="1700" b="1">
+                <a:solidFill>
+                  <a:srgbClr val="138A5E"/>
+                </a:solidFill>
+              </a:rPr>
+              <a:t>Pain point 3</a:t>
+            </a:r>
+          </a:p>
+        </p:txBody>
+      </p:sp>
+      <p:sp>
+        <p:nvSpPr>
+          <p:cNvPr id="100041" name="TextBox 15"/>
+          <p:cNvSpPr/>
+          <p:nvPr/>
+        </p:nvSpPr>
+        <p:spPr>
+          <a:xfrm>
+            <a:off x="5669280" y="3465576"/>
+            <a:ext cx="2331720" cy="886968"/>
+          </a:xfrm>
+          <a:prstGeom prst="rect">
+            <a:avLst/>
+          </a:prstGeom>
+          <a:noFill/>
+          <a:ln>
+            <a:noFill/>
+          </a:ln>
+        </p:spPr>
+        <p:txBody>
+          <a:bodyPr lIns="73152" tIns="73152" rIns="73152" bIns="73152"/>
+          <a:lstStyle/>
+          <a:p>
+            <a:pPr algn="l"/>
+            <a:r>
+              <a:rPr lang="en-US" sz="1200" b="0">
+                <a:solidFill>
+                  <a:srgbClr val="344563"/>
+                </a:solidFill>
+              </a:rPr>
+              <a:t>Digital confidence and language needs are overlooked.</a:t>
+            </a:r>
+          </a:p>
+        </p:txBody>
+      </p:sp>
     </p:spTree>
   </p:cSld>
   <p:clrMapOvr>
@@ -12619,6 +15281,477 @@
             <a:r>
               <a:rPr lang="en-IN" sz="2800"/>
               <a:t>Proposed solution</a:t>
+            </a:r>
+          </a:p>
+        </p:txBody>
+      </p:sp>
+      <p:sp>
+        <p:nvSpPr>
+          <p:cNvPr id="100042" name="TextBox 2"/>
+          <p:cNvSpPr/>
+          <p:nvPr/>
+        </p:nvSpPr>
+        <p:spPr>
+          <a:xfrm>
+            <a:off x="640080" y="1143000"/>
+            <a:ext cx="6858000" cy="411480"/>
+          </a:xfrm>
+          <a:prstGeom prst="rect">
+            <a:avLst/>
+          </a:prstGeom>
+          <a:noFill/>
+          <a:ln>
+            <a:noFill/>
+          </a:ln>
+        </p:spPr>
+        <p:txBody>
+          <a:bodyPr lIns="73152" tIns="73152" rIns="73152" bIns="73152"/>
+          <a:lstStyle/>
+          <a:p>
+            <a:pPr algn="ctr"/>
+            <a:r>
+              <a:rPr lang="en-US" sz="1800" b="1">
+                <a:solidFill>
+                  <a:srgbClr val="172B4D"/>
+                </a:solidFill>
+              </a:rPr>
+              <a:t>One connected flow from conversation to action</a:t>
+            </a:r>
+          </a:p>
+        </p:txBody>
+      </p:sp>
+      <p:sp>
+        <p:nvSpPr>
+          <p:cNvPr id="100043" name="TextBox 3"/>
+          <p:cNvSpPr/>
+          <p:nvPr/>
+        </p:nvSpPr>
+        <p:spPr>
+          <a:xfrm>
+            <a:off x="502920" y="1920240"/>
+            <a:ext cx="1325880" cy="640080"/>
+          </a:xfrm>
+          <a:prstGeom prst="roundRect">
+            <a:avLst/>
+          </a:prstGeom>
+          <a:solidFill>
+            <a:srgbClr val="145DA0"/>
+          </a:solidFill>
+          <a:ln>
+            <a:noFill/>
+          </a:ln>
+        </p:spPr>
+        <p:txBody>
+          <a:bodyPr lIns="73152" tIns="73152" rIns="73152" bIns="73152"/>
+          <a:lstStyle/>
+          <a:p>
+            <a:pPr algn="ctr"/>
+            <a:r>
+              <a:rPr lang="en-US" sz="1500" b="1">
+                <a:solidFill>
+                  <a:srgbClr val="FFFFFF"/>
+                </a:solidFill>
+              </a:rPr>
+              <a:t>Mobile app</a:t>
+            </a:r>
+          </a:p>
+        </p:txBody>
+      </p:sp>
+      <p:sp>
+        <p:nvSpPr>
+          <p:cNvPr id="100044" name="TextBox 4"/>
+          <p:cNvSpPr/>
+          <p:nvPr/>
+        </p:nvSpPr>
+        <p:spPr>
+          <a:xfrm>
+            <a:off x="1874520" y="2075688"/>
+            <a:ext cx="502920" cy="320040"/>
+          </a:xfrm>
+          <a:prstGeom prst="rightArrow">
+            <a:avLst/>
+          </a:prstGeom>
+          <a:noFill/>
+          <a:ln>
+            <a:noFill/>
+          </a:ln>
+        </p:spPr>
+        <p:txBody>
+          <a:bodyPr lIns="73152" tIns="73152" rIns="73152" bIns="73152"/>
+          <a:lstStyle/>
+          <a:p>
+            <a:pPr algn="ctr"/>
+            <a:r>
+              <a:rPr lang="en-US" sz="2400" b="1">
+                <a:solidFill>
+                  <a:srgbClr val="F97316"/>
+                </a:solidFill>
+              </a:rPr>
+              <a:t>&gt;</a:t>
+            </a:r>
+          </a:p>
+        </p:txBody>
+      </p:sp>
+      <p:sp>
+        <p:nvSpPr>
+          <p:cNvPr id="100045" name="TextBox 5"/>
+          <p:cNvSpPr/>
+          <p:nvPr/>
+        </p:nvSpPr>
+        <p:spPr>
+          <a:xfrm>
+            <a:off x="2423160" y="1920240"/>
+            <a:ext cx="1234440" cy="640080"/>
+          </a:xfrm>
+          <a:prstGeom prst="roundRect">
+            <a:avLst/>
+          </a:prstGeom>
+          <a:solidFill>
+            <a:srgbClr val="F97316"/>
+          </a:solidFill>
+          <a:ln>
+            <a:noFill/>
+          </a:ln>
+        </p:spPr>
+        <p:txBody>
+          <a:bodyPr lIns="73152" tIns="73152" rIns="73152" bIns="73152"/>
+          <a:lstStyle/>
+          <a:p>
+            <a:pPr algn="ctr"/>
+            <a:r>
+              <a:rPr lang="en-US" sz="1500" b="1">
+                <a:solidFill>
+                  <a:srgbClr val="FFFFFF"/>
+                </a:solidFill>
+              </a:rPr>
+              <a:t>FastAPI</a:t>
+            </a:r>
+          </a:p>
+        </p:txBody>
+      </p:sp>
+      <p:sp>
+        <p:nvSpPr>
+          <p:cNvPr id="100046" name="TextBox 6"/>
+          <p:cNvSpPr/>
+          <p:nvPr/>
+        </p:nvSpPr>
+        <p:spPr>
+          <a:xfrm>
+            <a:off x="3657600" y="2075688"/>
+            <a:ext cx="502920" cy="320040"/>
+          </a:xfrm>
+          <a:prstGeom prst="rightArrow">
+            <a:avLst/>
+          </a:prstGeom>
+          <a:noFill/>
+          <a:ln>
+            <a:noFill/>
+          </a:ln>
+        </p:spPr>
+        <p:txBody>
+          <a:bodyPr lIns="73152" tIns="73152" rIns="73152" bIns="73152"/>
+          <a:lstStyle/>
+          <a:p>
+            <a:pPr algn="ctr"/>
+            <a:r>
+              <a:rPr lang="en-US" sz="2400" b="1">
+                <a:solidFill>
+                  <a:srgbClr val="F97316"/>
+                </a:solidFill>
+              </a:rPr>
+              <a:t>&gt;</a:t>
+            </a:r>
+          </a:p>
+        </p:txBody>
+      </p:sp>
+      <p:sp>
+        <p:nvSpPr>
+          <p:cNvPr id="100047" name="TextBox 7"/>
+          <p:cNvSpPr/>
+          <p:nvPr/>
+        </p:nvSpPr>
+        <p:spPr>
+          <a:xfrm>
+            <a:off x="4160520" y="1920240"/>
+            <a:ext cx="1234440" cy="640080"/>
+          </a:xfrm>
+          <a:prstGeom prst="roundRect">
+            <a:avLst/>
+          </a:prstGeom>
+          <a:solidFill>
+            <a:srgbClr val="7C3AED"/>
+          </a:solidFill>
+          <a:ln>
+            <a:noFill/>
+          </a:ln>
+        </p:spPr>
+        <p:txBody>
+          <a:bodyPr lIns="73152" tIns="73152" rIns="73152" bIns="73152"/>
+          <a:lstStyle/>
+          <a:p>
+            <a:pPr algn="ctr"/>
+            <a:r>
+              <a:rPr lang="en-US" sz="1500" b="1">
+                <a:solidFill>
+                  <a:srgbClr val="FFFFFF"/>
+                </a:solidFill>
+              </a:rPr>
+              <a:t>Assistant</a:t>
+            </a:r>
+          </a:p>
+        </p:txBody>
+      </p:sp>
+      <p:sp>
+        <p:nvSpPr>
+          <p:cNvPr id="100048" name="TextBox 8"/>
+          <p:cNvSpPr/>
+          <p:nvPr/>
+        </p:nvSpPr>
+        <p:spPr>
+          <a:xfrm>
+            <a:off x="5394960" y="2075688"/>
+            <a:ext cx="502920" cy="320040"/>
+          </a:xfrm>
+          <a:prstGeom prst="rightArrow">
+            <a:avLst/>
+          </a:prstGeom>
+          <a:noFill/>
+          <a:ln>
+            <a:noFill/>
+          </a:ln>
+        </p:spPr>
+        <p:txBody>
+          <a:bodyPr lIns="73152" tIns="73152" rIns="73152" bIns="73152"/>
+          <a:lstStyle/>
+          <a:p>
+            <a:pPr algn="ctr"/>
+            <a:r>
+              <a:rPr lang="en-US" sz="2400" b="1">
+                <a:solidFill>
+                  <a:srgbClr val="F97316"/>
+                </a:solidFill>
+              </a:rPr>
+              <a:t>&gt;</a:t>
+            </a:r>
+          </a:p>
+        </p:txBody>
+      </p:sp>
+      <p:sp>
+        <p:nvSpPr>
+          <p:cNvPr id="100049" name="TextBox 9"/>
+          <p:cNvSpPr/>
+          <p:nvPr/>
+        </p:nvSpPr>
+        <p:spPr>
+          <a:xfrm>
+            <a:off x="5897880" y="1920240"/>
+            <a:ext cx="1417320" cy="640080"/>
+          </a:xfrm>
+          <a:prstGeom prst="roundRect">
+            <a:avLst/>
+          </a:prstGeom>
+          <a:solidFill>
+            <a:srgbClr val="138A5E"/>
+          </a:solidFill>
+          <a:ln>
+            <a:noFill/>
+          </a:ln>
+        </p:spPr>
+        <p:txBody>
+          <a:bodyPr lIns="73152" tIns="73152" rIns="73152" bIns="73152"/>
+          <a:lstStyle/>
+          <a:p>
+            <a:pPr algn="ctr"/>
+            <a:r>
+              <a:rPr lang="en-US" sz="1500" b="1">
+                <a:solidFill>
+                  <a:srgbClr val="FFFFFF"/>
+                </a:solidFill>
+              </a:rPr>
+              <a:t>Rules engine</a:t>
+            </a:r>
+          </a:p>
+        </p:txBody>
+      </p:sp>
+      <p:sp>
+        <p:nvSpPr>
+          <p:cNvPr id="100050" name="TextBox 10"/>
+          <p:cNvSpPr/>
+          <p:nvPr/>
+        </p:nvSpPr>
+        <p:spPr>
+          <a:xfrm>
+            <a:off x="548640" y="3246120"/>
+            <a:ext cx="1645920" cy="594360"/>
+          </a:xfrm>
+          <a:prstGeom prst="roundRect">
+            <a:avLst/>
+          </a:prstGeom>
+          <a:solidFill>
+            <a:srgbClr val="E8F1FF"/>
+          </a:solidFill>
+          <a:ln>
+            <a:noFill/>
+          </a:ln>
+        </p:spPr>
+        <p:txBody>
+          <a:bodyPr lIns="73152" tIns="73152" rIns="73152" bIns="73152"/>
+          <a:lstStyle/>
+          <a:p>
+            <a:pPr algn="ctr"/>
+            <a:r>
+              <a:rPr lang="en-US" sz="1400" b="1">
+                <a:solidFill>
+                  <a:srgbClr val="172B4D"/>
+                </a:solidFill>
+              </a:rPr>
+              <a:t>Profile + language</a:t>
+            </a:r>
+          </a:p>
+        </p:txBody>
+      </p:sp>
+      <p:sp>
+        <p:nvSpPr>
+          <p:cNvPr id="100051" name="TextBox 11"/>
+          <p:cNvSpPr/>
+          <p:nvPr/>
+        </p:nvSpPr>
+        <p:spPr>
+          <a:xfrm>
+            <a:off x="2560320" y="3246120"/>
+            <a:ext cx="1645920" cy="594360"/>
+          </a:xfrm>
+          <a:prstGeom prst="roundRect">
+            <a:avLst/>
+          </a:prstGeom>
+          <a:solidFill>
+            <a:srgbClr val="FFF7ED"/>
+          </a:solidFill>
+          <a:ln>
+            <a:noFill/>
+          </a:ln>
+        </p:spPr>
+        <p:txBody>
+          <a:bodyPr lIns="73152" tIns="73152" rIns="73152" bIns="73152"/>
+          <a:lstStyle/>
+          <a:p>
+            <a:pPr algn="ctr"/>
+            <a:r>
+              <a:rPr lang="en-US" sz="1400" b="1">
+                <a:solidFill>
+                  <a:srgbClr val="172B4D"/>
+                </a:solidFill>
+              </a:rPr>
+              <a:t>Verified schemes</a:t>
+            </a:r>
+          </a:p>
+        </p:txBody>
+      </p:sp>
+      <p:sp>
+        <p:nvSpPr>
+          <p:cNvPr id="100052" name="TextBox 12"/>
+          <p:cNvSpPr/>
+          <p:nvPr/>
+        </p:nvSpPr>
+        <p:spPr>
+          <a:xfrm>
+            <a:off x="4572000" y="3246120"/>
+            <a:ext cx="1874520" cy="594360"/>
+          </a:xfrm>
+          <a:prstGeom prst="roundRect">
+            <a:avLst/>
+          </a:prstGeom>
+          <a:solidFill>
+            <a:srgbClr val="ECFDF3"/>
+          </a:solidFill>
+          <a:ln>
+            <a:noFill/>
+          </a:ln>
+        </p:spPr>
+        <p:txBody>
+          <a:bodyPr lIns="73152" tIns="73152" rIns="73152" bIns="73152"/>
+          <a:lstStyle/>
+          <a:p>
+            <a:pPr algn="ctr"/>
+            <a:r>
+              <a:rPr lang="en-US" sz="1400" b="1">
+                <a:solidFill>
+                  <a:srgbClr val="172B4D"/>
+                </a:solidFill>
+              </a:rPr>
+              <a:t>Reasons + missing data</a:t>
+            </a:r>
+          </a:p>
+        </p:txBody>
+      </p:sp>
+      <p:sp>
+        <p:nvSpPr>
+          <p:cNvPr id="100053" name="TextBox 13"/>
+          <p:cNvSpPr/>
+          <p:nvPr/>
+        </p:nvSpPr>
+        <p:spPr>
+          <a:xfrm>
+            <a:off x="2834640" y="4572000"/>
+            <a:ext cx="1920240" cy="594360"/>
+          </a:xfrm>
+          <a:prstGeom prst="roundRect">
+            <a:avLst/>
+          </a:prstGeom>
+          <a:solidFill>
+            <a:srgbClr val="0F2747"/>
+          </a:solidFill>
+          <a:ln>
+            <a:noFill/>
+          </a:ln>
+        </p:spPr>
+        <p:txBody>
+          <a:bodyPr lIns="73152" tIns="73152" rIns="73152" bIns="73152"/>
+          <a:lstStyle/>
+          <a:p>
+            <a:pPr algn="ctr"/>
+            <a:r>
+              <a:rPr lang="en-US" sz="1500" b="1">
+                <a:solidFill>
+                  <a:srgbClr val="FFFFFF"/>
+                </a:solidFill>
+              </a:rPr>
+              <a:t>Application plan</a:t>
+            </a:r>
+          </a:p>
+        </p:txBody>
+      </p:sp>
+      <p:sp>
+        <p:nvSpPr>
+          <p:cNvPr id="100054" name="TextBox 14"/>
+          <p:cNvSpPr/>
+          <p:nvPr/>
+        </p:nvSpPr>
+        <p:spPr>
+          <a:xfrm>
+            <a:off x="3547872" y="3913632"/>
+            <a:ext cx="502920" cy="502920"/>
+          </a:xfrm>
+          <a:prstGeom prst="rightArrow">
+            <a:avLst/>
+          </a:prstGeom>
+          <a:noFill/>
+          <a:ln>
+            <a:noFill/>
+          </a:ln>
+        </p:spPr>
+        <p:txBody>
+          <a:bodyPr lIns="73152" tIns="73152" rIns="73152" bIns="73152"/>
+          <a:lstStyle/>
+          <a:p>
+            <a:pPr algn="ctr"/>
+            <a:r>
+              <a:rPr lang="en-US" sz="2400" b="1">
+                <a:solidFill>
+                  <a:srgbClr val="F97316"/>
+                </a:solidFill>
+              </a:rPr>
+              <a:t>&gt;</a:t>
             </a:r>
           </a:p>
         </p:txBody>

</xml_diff>